<commit_message>
Add MCP constellation architecture + expand deck to 16 slides
- track1-01.md: new "Architecture — a constellation of composable MCP
  endpoints" section (ITK-SNAP is not a DLS pass-through; MCP at both
  layers; endpoint table for ITK-SNAP/DLS/greedy/SegFlow4D/c3d/ConvertMesh/
  cmrep with Track 1 scope discipline).
- ideas.md, track2-01.md: mirror the multi-MCP constellation framing.
- deck/ideas.pptx (+build.js): +3 slides (use cases in practice,
  technical feasibility on shipped code, deployment model); renamed the
  coding-agent slide to "Delivery capacity"; now 16 slides.

Co-Authored-By: Claude Opus 4.8 <noreply@anthropic.com>
</commit_message>
<xml_diff>
--- a/projects/os4ls-grant-2026/deck/ideas.pptx
+++ b/projects/os4ls-grant-2026/deck/ideas.pptx
@@ -18,9 +18,12 @@
     <p:sldId id="266" r:id="rId12"/>
     <p:sldId id="267" r:id="rId13"/>
     <p:sldId id="268" r:id="rId14"/>
+    <p:sldId id="269" r:id="rId15"/>
+    <p:sldId id="270" r:id="rId16"/>
+    <p:sldId id="271" r:id="rId17"/>
   </p:sldIdLst>
   <p:notesMasterIdLst>
-    <p:notesMasterId r:id="rId15"/>
+    <p:notesMasterId r:id="rId18"/>
   </p:notesMasterIdLst>
   <p:sldSz cx="12192000" cy="6858000"/>
   <p:notesSz cx="6858000" cy="12192000"/>
@@ -890,6 +893,270 @@
             <a:fld id="{F7021451-1387-4CA6-816F-3879F97B5CBC}" type="slidenum">
               <a:rPr lang="en-US"/>
               <a:t>13</a:t>
+            </a:fld>
+            <a:endParaRPr lang="en-US"/>
+          </a:p>
+        </p:txBody>
+      </p:sp>
+    </p:spTree>
+    <p:extLst>
+      <p:ext uri="{BB962C8B-B14F-4D97-AF65-F5344CB8AC3E}">
+        <p14:creationId xmlns:p14="http://schemas.microsoft.com/office/powerpoint/2010/main" val="1024086991"/>
+      </p:ext>
+    </p:extLst>
+  </p:cSld>
+  <p:clrMapOvr>
+    <a:masterClrMapping/>
+  </p:clrMapOvr>
+</p:notes>
+</file>
+
+<file path=ppt/notesSlides/notesSlide14.xml><?xml version="1.0" encoding="utf-8"?>
+<p:notes xmlns:a="http://schemas.openxmlformats.org/drawingml/2006/main" xmlns:r="http://schemas.openxmlformats.org/officeDocument/2006/relationships" xmlns:p="http://schemas.openxmlformats.org/presentationml/2006/main">
+  <p:cSld>
+    <p:spTree>
+      <p:nvGrpSpPr>
+        <p:cNvPr id="1" name=""/>
+        <p:cNvGrpSpPr/>
+        <p:nvPr/>
+      </p:nvGrpSpPr>
+      <p:grpSpPr>
+        <a:xfrm>
+          <a:off x="0" y="0"/>
+          <a:ext cx="0" cy="0"/>
+          <a:chOff x="0" y="0"/>
+          <a:chExt cx="0" cy="0"/>
+        </a:xfrm>
+      </p:grpSpPr>
+      <p:sp>
+        <p:nvSpPr>
+          <p:cNvPr id="2" name="Slide Image Placeholder 1"/>
+          <p:cNvSpPr>
+            <a:spLocks noGrp="1" noRot="1" noChangeAspect="1"/>
+          </p:cNvSpPr>
+          <p:nvPr>
+            <p:ph type="sldImg"/>
+          </p:nvPr>
+        </p:nvSpPr>
+        <p:spPr/>
+      </p:sp>
+      <p:sp>
+        <p:nvSpPr>
+          <p:cNvPr id="3" name="Notes Placeholder 2"/>
+          <p:cNvSpPr>
+            <a:spLocks noGrp="1"/>
+          </p:cNvSpPr>
+          <p:nvPr>
+            <p:ph type="body" idx="1"/>
+          </p:nvPr>
+        </p:nvSpPr>
+        <p:spPr/>
+        <p:txBody>
+          <a:bodyPr/>
+          <a:lstStyle/>
+          <a:p>
+            <a:r>
+              <a:rPr lang="en-US" dirty="0"/>
+              <a:t/>
+            </a:r>
+            <a:endParaRPr lang="en-US" dirty="0"/>
+          </a:p>
+        </p:txBody>
+      </p:sp>
+      <p:sp>
+        <p:nvSpPr>
+          <p:cNvPr id="4" name="Slide Number Placeholder 3"/>
+          <p:cNvSpPr>
+            <a:spLocks noGrp="1"/>
+          </p:cNvSpPr>
+          <p:nvPr>
+            <p:ph type="sldNum" sz="quarter" idx="10"/>
+          </p:nvPr>
+        </p:nvSpPr>
+        <p:spPr/>
+        <p:txBody>
+          <a:bodyPr/>
+          <a:lstStyle/>
+          <a:p>
+            <a:fld id="{F7021451-1387-4CA6-816F-3879F97B5CBC}" type="slidenum">
+              <a:rPr lang="en-US"/>
+              <a:t>14</a:t>
+            </a:fld>
+            <a:endParaRPr lang="en-US"/>
+          </a:p>
+        </p:txBody>
+      </p:sp>
+    </p:spTree>
+    <p:extLst>
+      <p:ext uri="{BB962C8B-B14F-4D97-AF65-F5344CB8AC3E}">
+        <p14:creationId xmlns:p14="http://schemas.microsoft.com/office/powerpoint/2010/main" val="1024086991"/>
+      </p:ext>
+    </p:extLst>
+  </p:cSld>
+  <p:clrMapOvr>
+    <a:masterClrMapping/>
+  </p:clrMapOvr>
+</p:notes>
+</file>
+
+<file path=ppt/notesSlides/notesSlide15.xml><?xml version="1.0" encoding="utf-8"?>
+<p:notes xmlns:a="http://schemas.openxmlformats.org/drawingml/2006/main" xmlns:r="http://schemas.openxmlformats.org/officeDocument/2006/relationships" xmlns:p="http://schemas.openxmlformats.org/presentationml/2006/main">
+  <p:cSld>
+    <p:spTree>
+      <p:nvGrpSpPr>
+        <p:cNvPr id="1" name=""/>
+        <p:cNvGrpSpPr/>
+        <p:nvPr/>
+      </p:nvGrpSpPr>
+      <p:grpSpPr>
+        <a:xfrm>
+          <a:off x="0" y="0"/>
+          <a:ext cx="0" cy="0"/>
+          <a:chOff x="0" y="0"/>
+          <a:chExt cx="0" cy="0"/>
+        </a:xfrm>
+      </p:grpSpPr>
+      <p:sp>
+        <p:nvSpPr>
+          <p:cNvPr id="2" name="Slide Image Placeholder 1"/>
+          <p:cNvSpPr>
+            <a:spLocks noGrp="1" noRot="1" noChangeAspect="1"/>
+          </p:cNvSpPr>
+          <p:nvPr>
+            <p:ph type="sldImg"/>
+          </p:nvPr>
+        </p:nvSpPr>
+        <p:spPr/>
+      </p:sp>
+      <p:sp>
+        <p:nvSpPr>
+          <p:cNvPr id="3" name="Notes Placeholder 2"/>
+          <p:cNvSpPr>
+            <a:spLocks noGrp="1"/>
+          </p:cNvSpPr>
+          <p:nvPr>
+            <p:ph type="body" idx="1"/>
+          </p:nvPr>
+        </p:nvSpPr>
+        <p:spPr/>
+        <p:txBody>
+          <a:bodyPr/>
+          <a:lstStyle/>
+          <a:p>
+            <a:r>
+              <a:rPr lang="en-US" dirty="0"/>
+              <a:t/>
+            </a:r>
+            <a:endParaRPr lang="en-US" dirty="0"/>
+          </a:p>
+        </p:txBody>
+      </p:sp>
+      <p:sp>
+        <p:nvSpPr>
+          <p:cNvPr id="4" name="Slide Number Placeholder 3"/>
+          <p:cNvSpPr>
+            <a:spLocks noGrp="1"/>
+          </p:cNvSpPr>
+          <p:nvPr>
+            <p:ph type="sldNum" sz="quarter" idx="10"/>
+          </p:nvPr>
+        </p:nvSpPr>
+        <p:spPr/>
+        <p:txBody>
+          <a:bodyPr/>
+          <a:lstStyle/>
+          <a:p>
+            <a:fld id="{F7021451-1387-4CA6-816F-3879F97B5CBC}" type="slidenum">
+              <a:rPr lang="en-US"/>
+              <a:t>15</a:t>
+            </a:fld>
+            <a:endParaRPr lang="en-US"/>
+          </a:p>
+        </p:txBody>
+      </p:sp>
+    </p:spTree>
+    <p:extLst>
+      <p:ext uri="{BB962C8B-B14F-4D97-AF65-F5344CB8AC3E}">
+        <p14:creationId xmlns:p14="http://schemas.microsoft.com/office/powerpoint/2010/main" val="1024086991"/>
+      </p:ext>
+    </p:extLst>
+  </p:cSld>
+  <p:clrMapOvr>
+    <a:masterClrMapping/>
+  </p:clrMapOvr>
+</p:notes>
+</file>
+
+<file path=ppt/notesSlides/notesSlide16.xml><?xml version="1.0" encoding="utf-8"?>
+<p:notes xmlns:a="http://schemas.openxmlformats.org/drawingml/2006/main" xmlns:r="http://schemas.openxmlformats.org/officeDocument/2006/relationships" xmlns:p="http://schemas.openxmlformats.org/presentationml/2006/main">
+  <p:cSld>
+    <p:spTree>
+      <p:nvGrpSpPr>
+        <p:cNvPr id="1" name=""/>
+        <p:cNvGrpSpPr/>
+        <p:nvPr/>
+      </p:nvGrpSpPr>
+      <p:grpSpPr>
+        <a:xfrm>
+          <a:off x="0" y="0"/>
+          <a:ext cx="0" cy="0"/>
+          <a:chOff x="0" y="0"/>
+          <a:chExt cx="0" cy="0"/>
+        </a:xfrm>
+      </p:grpSpPr>
+      <p:sp>
+        <p:nvSpPr>
+          <p:cNvPr id="2" name="Slide Image Placeholder 1"/>
+          <p:cNvSpPr>
+            <a:spLocks noGrp="1" noRot="1" noChangeAspect="1"/>
+          </p:cNvSpPr>
+          <p:nvPr>
+            <p:ph type="sldImg"/>
+          </p:nvPr>
+        </p:nvSpPr>
+        <p:spPr/>
+      </p:sp>
+      <p:sp>
+        <p:nvSpPr>
+          <p:cNvPr id="3" name="Notes Placeholder 2"/>
+          <p:cNvSpPr>
+            <a:spLocks noGrp="1"/>
+          </p:cNvSpPr>
+          <p:nvPr>
+            <p:ph type="body" idx="1"/>
+          </p:nvPr>
+        </p:nvSpPr>
+        <p:spPr/>
+        <p:txBody>
+          <a:bodyPr/>
+          <a:lstStyle/>
+          <a:p>
+            <a:r>
+              <a:rPr lang="en-US" dirty="0"/>
+              <a:t/>
+            </a:r>
+            <a:endParaRPr lang="en-US" dirty="0"/>
+          </a:p>
+        </p:txBody>
+      </p:sp>
+      <p:sp>
+        <p:nvSpPr>
+          <p:cNvPr id="4" name="Slide Number Placeholder 3"/>
+          <p:cNvSpPr>
+            <a:spLocks noGrp="1"/>
+          </p:cNvSpPr>
+          <p:nvPr>
+            <p:ph type="sldNum" sz="quarter" idx="10"/>
+          </p:nvPr>
+        </p:nvSpPr>
+        <p:spPr/>
+        <p:txBody>
+          <a:bodyPr/>
+          <a:lstStyle/>
+          <a:p>
+            <a:fld id="{F7021451-1387-4CA6-816F-3879F97B5CBC}" type="slidenum">
+              <a:rPr lang="en-US"/>
+              <a:t>16</a:t>
             </a:fld>
             <a:endParaRPr lang="en-US"/>
           </a:p>
@@ -3285,7 +3552,7 @@
                 <a:ea typeface="Trebuchet MS" pitchFamily="34" charset="-122"/>
                 <a:cs typeface="Trebuchet MS" pitchFamily="34" charset="-120"/>
               </a:rPr>
-              <a:t>FEASIBILITY</a:t>
+              <a:t>USE CASES</a:t>
             </a:r>
             <a:endParaRPr lang="en-US" sz="1300" dirty="0"/>
           </a:p>
@@ -3324,7 +3591,7 @@
                 <a:ea typeface="Trebuchet MS" pitchFamily="34" charset="-122"/>
                 <a:cs typeface="Trebuchet MS" pitchFamily="34" charset="-120"/>
               </a:rPr>
-              <a:t>Why this is achievable in a 2-year scope</a:t>
+              <a:t>What it looks like in practice</a:t>
             </a:r>
             <a:endParaRPr lang="en-US" sz="2700" dirty="0"/>
           </a:p>
@@ -3332,18 +3599,57 @@
       </p:sp>
       <p:sp>
         <p:nvSpPr>
-          <p:cNvPr id="5" name="Shape 3"/>
-          <p:cNvSpPr/>
-          <p:nvPr/>
-        </p:nvSpPr>
-        <p:spPr>
-          <a:xfrm>
-            <a:off x="548640" y="1691640"/>
-            <a:ext cx="5362956" cy="1783080"/>
+          <p:cNvPr id="5" name="Text 3"/>
+          <p:cNvSpPr/>
+          <p:nvPr/>
+        </p:nvSpPr>
+        <p:spPr>
+          <a:xfrm>
+            <a:off x="804672" y="1261872"/>
+            <a:ext cx="11155680" cy="365760"/>
+          </a:xfrm>
+          <a:prstGeom prst="rect">
+            <a:avLst/>
+          </a:prstGeom>
+          <a:noFill/>
+          <a:ln/>
+        </p:spPr>
+        <p:txBody>
+          <a:bodyPr wrap="square" lIns="0" tIns="0" rIns="0" bIns="0" rtlCol="0" anchor="ctr"/>
+          <a:lstStyle/>
+          <a:p>
+            <a:pPr indent="0" marL="0">
+              <a:buNone/>
+            </a:pPr>
+            <a:r>
+              <a:rPr lang="en-US" sz="1400" i="1" dirty="0">
+                <a:solidFill>
+                  <a:srgbClr val="33495C"/>
+                </a:solidFill>
+                <a:latin typeface="Calibri" pitchFamily="34" charset="0"/>
+                <a:ea typeface="Calibri" pitchFamily="34" charset="-122"/>
+                <a:cs typeface="Calibri" pitchFamily="34" charset="-120"/>
+              </a:rPr>
+              <a:t>Automation does the rote work; the expert is pulled in only where judgment matters.</a:t>
+            </a:r>
+            <a:endParaRPr lang="en-US" sz="1400" dirty="0"/>
+          </a:p>
+        </p:txBody>
+      </p:sp>
+      <p:sp>
+        <p:nvSpPr>
+          <p:cNvPr id="6" name="Shape 4"/>
+          <p:cNvSpPr/>
+          <p:nvPr/>
+        </p:nvSpPr>
+        <p:spPr>
+          <a:xfrm>
+            <a:off x="548640" y="1828800"/>
+            <a:ext cx="5362956" cy="1691640"/>
           </a:xfrm>
           <a:prstGeom prst="roundRect">
             <a:avLst>
-              <a:gd name="adj" fmla="val 4103"/>
+              <a:gd name="adj" fmla="val 4324"/>
             </a:avLst>
           </a:prstGeom>
           <a:solidFill>
@@ -3366,14 +3672,14 @@
       </p:sp>
       <p:sp>
         <p:nvSpPr>
-          <p:cNvPr id="6" name="Shape 4"/>
-          <p:cNvSpPr/>
-          <p:nvPr/>
-        </p:nvSpPr>
-        <p:spPr>
-          <a:xfrm>
-            <a:off x="841248" y="2039112"/>
-            <a:ext cx="713232" cy="713232"/>
+          <p:cNvPr id="7" name="Shape 5"/>
+          <p:cNvSpPr/>
+          <p:nvPr/>
+        </p:nvSpPr>
+        <p:spPr>
+          <a:xfrm>
+            <a:off x="841248" y="2139696"/>
+            <a:ext cx="676656" cy="676656"/>
           </a:xfrm>
           <a:prstGeom prst="ellipse">
             <a:avLst/>
@@ -3386,7 +3692,7 @@
       </p:sp>
       <p:pic>
         <p:nvPicPr>
-          <p:cNvPr id="7" name="Image 0" descr="preencoded.png">    </p:cNvPr>
+          <p:cNvPr id="8" name="Image 0" descr="preencoded.png">    </p:cNvPr>
           <p:cNvPicPr>
             <a:picLocks noChangeAspect="1"/>
           </p:cNvPicPr>
@@ -3400,8 +3706,8 @@
         </p:blipFill>
         <p:spPr>
           <a:xfrm>
-            <a:off x="1042416" y="2240280"/>
-            <a:ext cx="310896" cy="310896"/>
+            <a:off x="1033272" y="2331720"/>
+            <a:ext cx="292608" cy="292608"/>
           </a:xfrm>
           <a:prstGeom prst="rect">
             <a:avLst/>
@@ -3410,14 +3716,14 @@
       </p:pic>
       <p:sp>
         <p:nvSpPr>
-          <p:cNvPr id="8" name="Text 5"/>
-          <p:cNvSpPr/>
-          <p:nvPr/>
-        </p:nvSpPr>
-        <p:spPr>
-          <a:xfrm>
-            <a:off x="1783080" y="1984248"/>
-            <a:ext cx="3899916" cy="411480"/>
+          <p:cNvPr id="9" name="Text 6"/>
+          <p:cNvSpPr/>
+          <p:nvPr/>
+        </p:nvSpPr>
+        <p:spPr>
+          <a:xfrm>
+            <a:off x="1737360" y="2103120"/>
+            <a:ext cx="3945636" cy="365760"/>
           </a:xfrm>
           <a:prstGeom prst="rect">
             <a:avLst/>
@@ -3433,7 +3739,7 @@
               <a:buNone/>
             </a:pPr>
             <a:r>
-              <a:rPr lang="en-US" sz="1700" b="1" dirty="0">
+              <a:rPr lang="en-US" sz="1600" b="1" dirty="0">
                 <a:solidFill>
                   <a:srgbClr val="0B2545"/>
                 </a:solidFill>
@@ -3441,22 +3747,22 @@
                 <a:ea typeface="Trebuchet MS" pitchFamily="34" charset="-122"/>
                 <a:cs typeface="Trebuchet MS" pitchFamily="34" charset="-120"/>
               </a:rPr>
-              <a:t>Coding-agent multiplier</a:t>
-            </a:r>
-            <a:endParaRPr lang="en-US" sz="1700" dirty="0"/>
-          </a:p>
-        </p:txBody>
-      </p:sp>
-      <p:sp>
-        <p:nvSpPr>
-          <p:cNvPr id="9" name="Text 6"/>
-          <p:cNvSpPr/>
-          <p:nvPr/>
-        </p:nvSpPr>
-        <p:spPr>
-          <a:xfrm>
-            <a:off x="1783080" y="2404872"/>
-            <a:ext cx="3899916" cy="960120"/>
+              <a:t>Cohort segmentation at scale</a:t>
+            </a:r>
+            <a:endParaRPr lang="en-US" sz="1600" dirty="0"/>
+          </a:p>
+        </p:txBody>
+      </p:sp>
+      <p:sp>
+        <p:nvSpPr>
+          <p:cNvPr id="10" name="Text 7"/>
+          <p:cNvSpPr/>
+          <p:nvPr/>
+        </p:nvSpPr>
+        <p:spPr>
+          <a:xfrm>
+            <a:off x="1737360" y="2487168"/>
+            <a:ext cx="3945636" cy="777240"/>
           </a:xfrm>
           <a:prstGeom prst="rect">
             <a:avLst/>
@@ -3472,7 +3778,7 @@
               <a:buNone/>
             </a:pPr>
             <a:r>
-              <a:rPr lang="en-US" sz="1250" dirty="0">
+              <a:rPr lang="en-US" sz="1200" dirty="0">
                 <a:solidFill>
                   <a:srgbClr val="33495C"/>
                 </a:solidFill>
@@ -3480,26 +3786,65 @@
                 <a:ea typeface="Calibri" pitchFamily="34" charset="-122"/>
                 <a:cs typeface="Calibri" pitchFamily="34" charset="-120"/>
               </a:rPr>
-              <a:t>Modern AI coding agents turn a ~3–4 FTE-year scope into something a focused team can deliver — and it dogfoods the very thing we're building.</a:t>
-            </a:r>
-            <a:endParaRPr lang="en-US" sz="1250" dirty="0"/>
-          </a:p>
-        </p:txBody>
-      </p:sp>
-      <p:sp>
-        <p:nvSpPr>
-          <p:cNvPr id="10" name="Shape 7"/>
-          <p:cNvSpPr/>
-          <p:nvPr/>
-        </p:nvSpPr>
-        <p:spPr>
-          <a:xfrm>
-            <a:off x="6277356" y="1691640"/>
-            <a:ext cx="5362956" cy="1783080"/>
+              <a:t>Agent segments 200 scans; the expert reviews only the ~12 flagged. Every decision logged.</a:t>
+            </a:r>
+            <a:endParaRPr lang="en-US" sz="1200" dirty="0"/>
+          </a:p>
+        </p:txBody>
+      </p:sp>
+      <p:sp>
+        <p:nvSpPr>
+          <p:cNvPr id="11" name="Text 8"/>
+          <p:cNvSpPr/>
+          <p:nvPr/>
+        </p:nvSpPr>
+        <p:spPr>
+          <a:xfrm>
+            <a:off x="1737360" y="3154680"/>
+            <a:ext cx="3945636" cy="274320"/>
+          </a:xfrm>
+          <a:prstGeom prst="rect">
+            <a:avLst/>
+          </a:prstGeom>
+          <a:noFill/>
+          <a:ln/>
+        </p:spPr>
+        <p:txBody>
+          <a:bodyPr wrap="square" lIns="0" tIns="0" rIns="0" bIns="0" rtlCol="0" anchor="ctr"/>
+          <a:lstStyle/>
+          <a:p>
+            <a:pPr indent="0" marL="0">
+              <a:buNone/>
+            </a:pPr>
+            <a:r>
+              <a:rPr lang="en-US" sz="1050" b="1" dirty="0">
+                <a:solidFill>
+                  <a:srgbClr val="1496A6"/>
+                </a:solidFill>
+                <a:latin typeface="Trebuchet MS" pitchFamily="34" charset="0"/>
+                <a:ea typeface="Trebuchet MS" pitchFamily="34" charset="-122"/>
+                <a:cs typeface="Trebuchet MS" pitchFamily="34" charset="-120"/>
+              </a:rPr>
+              <a:t>Aims 1 + 2</a:t>
+            </a:r>
+            <a:endParaRPr lang="en-US" sz="1050" dirty="0"/>
+          </a:p>
+        </p:txBody>
+      </p:sp>
+      <p:sp>
+        <p:nvSpPr>
+          <p:cNvPr id="12" name="Shape 9"/>
+          <p:cNvSpPr/>
+          <p:nvPr/>
+        </p:nvSpPr>
+        <p:spPr>
+          <a:xfrm>
+            <a:off x="6277356" y="1828800"/>
+            <a:ext cx="5362956" cy="1691640"/>
           </a:xfrm>
           <a:prstGeom prst="roundRect">
             <a:avLst>
-              <a:gd name="adj" fmla="val 4103"/>
+              <a:gd name="adj" fmla="val 4324"/>
             </a:avLst>
           </a:prstGeom>
           <a:solidFill>
@@ -3522,14 +3867,14 @@
       </p:sp>
       <p:sp>
         <p:nvSpPr>
-          <p:cNvPr id="11" name="Shape 8"/>
-          <p:cNvSpPr/>
-          <p:nvPr/>
-        </p:nvSpPr>
-        <p:spPr>
-          <a:xfrm>
-            <a:off x="6569964" y="2039112"/>
-            <a:ext cx="713232" cy="713232"/>
+          <p:cNvPr id="13" name="Shape 10"/>
+          <p:cNvSpPr/>
+          <p:nvPr/>
+        </p:nvSpPr>
+        <p:spPr>
+          <a:xfrm>
+            <a:off x="6569964" y="2139696"/>
+            <a:ext cx="676656" cy="676656"/>
           </a:xfrm>
           <a:prstGeom prst="ellipse">
             <a:avLst/>
@@ -3542,7 +3887,7 @@
       </p:sp>
       <p:pic>
         <p:nvPicPr>
-          <p:cNvPr id="12" name="Image 1" descr="preencoded.png">    </p:cNvPr>
+          <p:cNvPr id="14" name="Image 1" descr="preencoded.png">    </p:cNvPr>
           <p:cNvPicPr>
             <a:picLocks noChangeAspect="1"/>
           </p:cNvPicPr>
@@ -3556,8 +3901,8 @@
         </p:blipFill>
         <p:spPr>
           <a:xfrm>
-            <a:off x="6771132" y="2240280"/>
-            <a:ext cx="310896" cy="310896"/>
+            <a:off x="6761988" y="2331720"/>
+            <a:ext cx="292608" cy="292608"/>
           </a:xfrm>
           <a:prstGeom prst="rect">
             <a:avLst/>
@@ -3566,14 +3911,14 @@
       </p:pic>
       <p:sp>
         <p:nvSpPr>
-          <p:cNvPr id="13" name="Text 9"/>
-          <p:cNvSpPr/>
-          <p:nvPr/>
-        </p:nvSpPr>
-        <p:spPr>
-          <a:xfrm>
-            <a:off x="7511796" y="1984248"/>
-            <a:ext cx="3899916" cy="411480"/>
+          <p:cNvPr id="15" name="Text 11"/>
+          <p:cNvSpPr/>
+          <p:nvPr/>
+        </p:nvSpPr>
+        <p:spPr>
+          <a:xfrm>
+            <a:off x="7466076" y="2103120"/>
+            <a:ext cx="3945636" cy="365760"/>
           </a:xfrm>
           <a:prstGeom prst="rect">
             <a:avLst/>
@@ -3589,7 +3934,7 @@
               <a:buNone/>
             </a:pPr>
             <a:r>
-              <a:rPr lang="en-US" sz="1700" b="1" dirty="0">
+              <a:rPr lang="en-US" sz="1600" b="1" dirty="0">
                 <a:solidFill>
                   <a:srgbClr val="0B2545"/>
                 </a:solidFill>
@@ -3597,22 +3942,22 @@
                 <a:ea typeface="Trebuchet MS" pitchFamily="34" charset="-122"/>
                 <a:cs typeface="Trebuchet MS" pitchFamily="34" charset="-120"/>
               </a:rPr>
-              <a:t>Integration, not invention</a:t>
-            </a:r>
-            <a:endParaRPr lang="en-US" sz="1700" dirty="0"/>
-          </a:p>
-        </p:txBody>
-      </p:sp>
-      <p:sp>
-        <p:nvSpPr>
-          <p:cNvPr id="14" name="Text 10"/>
-          <p:cNvSpPr/>
-          <p:nvPr/>
-        </p:nvSpPr>
-        <p:spPr>
-          <a:xfrm>
-            <a:off x="7511796" y="2404872"/>
-            <a:ext cx="3899916" cy="960120"/>
+              <a:t>Valve → biomechanics</a:t>
+            </a:r>
+            <a:endParaRPr lang="en-US" sz="1600" dirty="0"/>
+          </a:p>
+        </p:txBody>
+      </p:sp>
+      <p:sp>
+        <p:nvSpPr>
+          <p:cNvPr id="16" name="Text 12"/>
+          <p:cNvSpPr/>
+          <p:nvPr/>
+        </p:nvSpPr>
+        <p:spPr>
+          <a:xfrm>
+            <a:off x="7466076" y="2487168"/>
+            <a:ext cx="3945636" cy="777240"/>
           </a:xfrm>
           <a:prstGeom prst="rect">
             <a:avLst/>
@@ -3628,7 +3973,7 @@
               <a:buNone/>
             </a:pPr>
             <a:r>
-              <a:rPr lang="en-US" sz="1250" dirty="0">
+              <a:rPr lang="en-US" sz="1200" dirty="0">
                 <a:solidFill>
                   <a:srgbClr val="33495C"/>
                 </a:solidFill>
@@ -3636,26 +3981,65 @@
                 <a:ea typeface="Calibri" pitchFamily="34" charset="-122"/>
                 <a:cs typeface="Calibri" pitchFamily="34" charset="-120"/>
               </a:rPr>
-              <a:t>Most work wires together mature components: itksnap-dls, greedy, SegFlow4D, FireANTs, WorkspaceAPI, MONAI, Hugging Face.</a:t>
-            </a:r>
-            <a:endParaRPr lang="en-US" sz="1250" dirty="0"/>
-          </a:p>
-        </p:txBody>
-      </p:sp>
-      <p:sp>
-        <p:nvSpPr>
-          <p:cNvPr id="15" name="Shape 11"/>
-          <p:cNvSpPr/>
-          <p:nvPr/>
-        </p:nvSpPr>
-        <p:spPr>
-          <a:xfrm>
-            <a:off x="548640" y="3657600"/>
-            <a:ext cx="5362956" cy="1783080"/>
+              <a:t>Segment the mitral valve, export a FEBio-ready mesh — 4D over the cardiac cycle.</a:t>
+            </a:r>
+            <a:endParaRPr lang="en-US" sz="1200" dirty="0"/>
+          </a:p>
+        </p:txBody>
+      </p:sp>
+      <p:sp>
+        <p:nvSpPr>
+          <p:cNvPr id="17" name="Text 13"/>
+          <p:cNvSpPr/>
+          <p:nvPr/>
+        </p:nvSpPr>
+        <p:spPr>
+          <a:xfrm>
+            <a:off x="7466076" y="3154680"/>
+            <a:ext cx="3945636" cy="274320"/>
+          </a:xfrm>
+          <a:prstGeom prst="rect">
+            <a:avLst/>
+          </a:prstGeom>
+          <a:noFill/>
+          <a:ln/>
+        </p:spPr>
+        <p:txBody>
+          <a:bodyPr wrap="square" lIns="0" tIns="0" rIns="0" bIns="0" rtlCol="0" anchor="ctr"/>
+          <a:lstStyle/>
+          <a:p>
+            <a:pPr indent="0" marL="0">
+              <a:buNone/>
+            </a:pPr>
+            <a:r>
+              <a:rPr lang="en-US" sz="1050" b="1" dirty="0">
+                <a:solidFill>
+                  <a:srgbClr val="E8924A"/>
+                </a:solidFill>
+                <a:latin typeface="Trebuchet MS" pitchFamily="34" charset="0"/>
+                <a:ea typeface="Trebuchet MS" pitchFamily="34" charset="-122"/>
+                <a:cs typeface="Trebuchet MS" pitchFamily="34" charset="-120"/>
+              </a:rPr>
+              <a:t>Aims 1.3 + 4.2</a:t>
+            </a:r>
+            <a:endParaRPr lang="en-US" sz="1050" dirty="0"/>
+          </a:p>
+        </p:txBody>
+      </p:sp>
+      <p:sp>
+        <p:nvSpPr>
+          <p:cNvPr id="18" name="Shape 14"/>
+          <p:cNvSpPr/>
+          <p:nvPr/>
+        </p:nvSpPr>
+        <p:spPr>
+          <a:xfrm>
+            <a:off x="548640" y="3703320"/>
+            <a:ext cx="5362956" cy="1691640"/>
           </a:xfrm>
           <a:prstGeom prst="roundRect">
             <a:avLst>
-              <a:gd name="adj" fmla="val 4103"/>
+              <a:gd name="adj" fmla="val 4324"/>
             </a:avLst>
           </a:prstGeom>
           <a:solidFill>
@@ -3678,27 +4062,27 @@
       </p:sp>
       <p:sp>
         <p:nvSpPr>
-          <p:cNvPr id="16" name="Shape 12"/>
-          <p:cNvSpPr/>
-          <p:nvPr/>
-        </p:nvSpPr>
-        <p:spPr>
-          <a:xfrm>
-            <a:off x="841248" y="4005072"/>
-            <a:ext cx="713232" cy="713232"/>
+          <p:cNvPr id="19" name="Shape 15"/>
+          <p:cNvSpPr/>
+          <p:nvPr/>
+        </p:nvSpPr>
+        <p:spPr>
+          <a:xfrm>
+            <a:off x="841248" y="4014216"/>
+            <a:ext cx="676656" cy="676656"/>
           </a:xfrm>
           <a:prstGeom prst="ellipse">
             <a:avLst/>
           </a:prstGeom>
           <a:solidFill>
-            <a:srgbClr val="13678A"/>
+            <a:srgbClr val="2BB3A3"/>
           </a:solidFill>
           <a:ln/>
         </p:spPr>
       </p:sp>
       <p:pic>
         <p:nvPicPr>
-          <p:cNvPr id="17" name="Image 2" descr="preencoded.png">    </p:cNvPr>
+          <p:cNvPr id="20" name="Image 2" descr="preencoded.png">    </p:cNvPr>
           <p:cNvPicPr>
             <a:picLocks noChangeAspect="1"/>
           </p:cNvPicPr>
@@ -3712,8 +4096,8 @@
         </p:blipFill>
         <p:spPr>
           <a:xfrm>
-            <a:off x="1042416" y="4206240"/>
-            <a:ext cx="310896" cy="310896"/>
+            <a:off x="1033272" y="4206240"/>
+            <a:ext cx="292608" cy="292608"/>
           </a:xfrm>
           <a:prstGeom prst="rect">
             <a:avLst/>
@@ -3722,14 +4106,14 @@
       </p:pic>
       <p:sp>
         <p:nvSpPr>
-          <p:cNvPr id="18" name="Text 13"/>
-          <p:cNvSpPr/>
-          <p:nvPr/>
-        </p:nvSpPr>
-        <p:spPr>
-          <a:xfrm>
-            <a:off x="1783080" y="3950208"/>
-            <a:ext cx="3899916" cy="411480"/>
+          <p:cNvPr id="21" name="Text 16"/>
+          <p:cNvSpPr/>
+          <p:nvPr/>
+        </p:nvSpPr>
+        <p:spPr>
+          <a:xfrm>
+            <a:off x="1737360" y="3977640"/>
+            <a:ext cx="3945636" cy="365760"/>
           </a:xfrm>
           <a:prstGeom prst="rect">
             <a:avLst/>
@@ -3745,7 +4129,7 @@
               <a:buNone/>
             </a:pPr>
             <a:r>
-              <a:rPr lang="en-US" sz="1700" b="1" dirty="0">
+              <a:rPr lang="en-US" sz="1600" b="1" dirty="0">
                 <a:solidFill>
                   <a:srgbClr val="0B2545"/>
                 </a:solidFill>
@@ -3753,22 +4137,22 @@
                 <a:ea typeface="Trebuchet MS" pitchFamily="34" charset="-122"/>
                 <a:cs typeface="Trebuchet MS" pitchFamily="34" charset="-120"/>
               </a:rPr>
-              <a:t>Clean architecture</a:t>
-            </a:r>
-            <a:endParaRPr lang="en-US" sz="1700" dirty="0"/>
-          </a:p>
-        </p:txBody>
-      </p:sp>
-      <p:sp>
-        <p:nvSpPr>
-          <p:cNvPr id="19" name="Text 14"/>
-          <p:cNvSpPr/>
-          <p:nvPr/>
-        </p:nvSpPr>
-        <p:spPr>
-          <a:xfrm>
-            <a:off x="1783080" y="4370832"/>
-            <a:ext cx="3899916" cy="960120"/>
+              <a:t>Reader study &amp; auditable QC</a:t>
+            </a:r>
+            <a:endParaRPr lang="en-US" sz="1600" dirty="0"/>
+          </a:p>
+        </p:txBody>
+      </p:sp>
+      <p:sp>
+        <p:nvSpPr>
+          <p:cNvPr id="22" name="Text 17"/>
+          <p:cNvSpPr/>
+          <p:nvPr/>
+        </p:nvSpPr>
+        <p:spPr>
+          <a:xfrm>
+            <a:off x="1737360" y="4361688"/>
+            <a:ext cx="3945636" cy="777240"/>
           </a:xfrm>
           <a:prstGeom prst="rect">
             <a:avLst/>
@@ -3784,7 +4168,7 @@
               <a:buNone/>
             </a:pPr>
             <a:r>
-              <a:rPr lang="en-US" sz="1250" dirty="0">
+              <a:rPr lang="en-US" sz="1200" dirty="0">
                 <a:solidFill>
                   <a:srgbClr val="33495C"/>
                 </a:solidFill>
@@ -3792,26 +4176,65 @@
                 <a:ea typeface="Calibri" pitchFamily="34" charset="-122"/>
                 <a:cs typeface="Calibri" pitchFamily="34" charset="-120"/>
               </a:rPr>
-              <a:t>ITK-SNAP's strict three-layer separation gives agents clear contracts to target — fast, low-error work.</a:t>
-            </a:r>
-            <a:endParaRPr lang="en-US" sz="1250" dirty="0"/>
-          </a:p>
-        </p:txBody>
-      </p:sp>
-      <p:sp>
-        <p:nvSpPr>
-          <p:cNvPr id="20" name="Shape 15"/>
-          <p:cNvSpPr/>
-          <p:nvPr/>
-        </p:nvSpPr>
-        <p:spPr>
-          <a:xfrm>
-            <a:off x="6277356" y="3657600"/>
-            <a:ext cx="5362956" cy="1783080"/>
+              <a:t>Route cases to multiple readers; capture decisions + provenance for reliability/audit.</a:t>
+            </a:r>
+            <a:endParaRPr lang="en-US" sz="1200" dirty="0"/>
+          </a:p>
+        </p:txBody>
+      </p:sp>
+      <p:sp>
+        <p:nvSpPr>
+          <p:cNvPr id="23" name="Text 18"/>
+          <p:cNvSpPr/>
+          <p:nvPr/>
+        </p:nvSpPr>
+        <p:spPr>
+          <a:xfrm>
+            <a:off x="1737360" y="5029200"/>
+            <a:ext cx="3945636" cy="274320"/>
+          </a:xfrm>
+          <a:prstGeom prst="rect">
+            <a:avLst/>
+          </a:prstGeom>
+          <a:noFill/>
+          <a:ln/>
+        </p:spPr>
+        <p:txBody>
+          <a:bodyPr wrap="square" lIns="0" tIns="0" rIns="0" bIns="0" rtlCol="0" anchor="ctr"/>
+          <a:lstStyle/>
+          <a:p>
+            <a:pPr indent="0" marL="0">
+              <a:buNone/>
+            </a:pPr>
+            <a:r>
+              <a:rPr lang="en-US" sz="1050" b="1" dirty="0">
+                <a:solidFill>
+                  <a:srgbClr val="2BB3A3"/>
+                </a:solidFill>
+                <a:latin typeface="Trebuchet MS" pitchFamily="34" charset="0"/>
+                <a:ea typeface="Trebuchet MS" pitchFamily="34" charset="-122"/>
+                <a:cs typeface="Trebuchet MS" pitchFamily="34" charset="-120"/>
+              </a:rPr>
+              <a:t>Aim 1.3</a:t>
+            </a:r>
+            <a:endParaRPr lang="en-US" sz="1050" dirty="0"/>
+          </a:p>
+        </p:txBody>
+      </p:sp>
+      <p:sp>
+        <p:nvSpPr>
+          <p:cNvPr id="24" name="Shape 19"/>
+          <p:cNvSpPr/>
+          <p:nvPr/>
+        </p:nvSpPr>
+        <p:spPr>
+          <a:xfrm>
+            <a:off x="6277356" y="3703320"/>
+            <a:ext cx="5362956" cy="1691640"/>
           </a:xfrm>
           <a:prstGeom prst="roundRect">
             <a:avLst>
-              <a:gd name="adj" fmla="val 4103"/>
+              <a:gd name="adj" fmla="val 4324"/>
             </a:avLst>
           </a:prstGeom>
           <a:solidFill>
@@ -3834,27 +4257,27 @@
       </p:sp>
       <p:sp>
         <p:nvSpPr>
-          <p:cNvPr id="21" name="Shape 16"/>
-          <p:cNvSpPr/>
-          <p:nvPr/>
-        </p:nvSpPr>
-        <p:spPr>
-          <a:xfrm>
-            <a:off x="6569964" y="4005072"/>
-            <a:ext cx="713232" cy="713232"/>
+          <p:cNvPr id="25" name="Shape 20"/>
+          <p:cNvSpPr/>
+          <p:nvPr/>
+        </p:nvSpPr>
+        <p:spPr>
+          <a:xfrm>
+            <a:off x="6569964" y="4014216"/>
+            <a:ext cx="676656" cy="676656"/>
           </a:xfrm>
           <a:prstGeom prst="ellipse">
             <a:avLst/>
           </a:prstGeom>
           <a:solidFill>
-            <a:srgbClr val="2BB3A3"/>
+            <a:srgbClr val="13678A"/>
           </a:solidFill>
           <a:ln/>
         </p:spPr>
       </p:sp>
       <p:pic>
         <p:nvPicPr>
-          <p:cNvPr id="22" name="Image 3" descr="preencoded.png">    </p:cNvPr>
+          <p:cNvPr id="26" name="Image 3" descr="preencoded.png">    </p:cNvPr>
           <p:cNvPicPr>
             <a:picLocks noChangeAspect="1"/>
           </p:cNvPicPr>
@@ -3868,8 +4291,8 @@
         </p:blipFill>
         <p:spPr>
           <a:xfrm>
-            <a:off x="6771132" y="4206240"/>
-            <a:ext cx="310896" cy="310896"/>
+            <a:off x="6761988" y="4206240"/>
+            <a:ext cx="292608" cy="292608"/>
           </a:xfrm>
           <a:prstGeom prst="rect">
             <a:avLst/>
@@ -3878,14 +4301,14 @@
       </p:pic>
       <p:sp>
         <p:nvSpPr>
-          <p:cNvPr id="23" name="Text 17"/>
-          <p:cNvSpPr/>
-          <p:nvPr/>
-        </p:nvSpPr>
-        <p:spPr>
-          <a:xfrm>
-            <a:off x="7511796" y="3950208"/>
-            <a:ext cx="3899916" cy="411480"/>
+          <p:cNvPr id="27" name="Text 21"/>
+          <p:cNvSpPr/>
+          <p:nvPr/>
+        </p:nvSpPr>
+        <p:spPr>
+          <a:xfrm>
+            <a:off x="7466076" y="3977640"/>
+            <a:ext cx="3945636" cy="365760"/>
           </a:xfrm>
           <a:prstGeom prst="rect">
             <a:avLst/>
@@ -3901,7 +4324,7 @@
               <a:buNone/>
             </a:pPr>
             <a:r>
-              <a:rPr lang="en-US" sz="1700" b="1" dirty="0">
+              <a:rPr lang="en-US" sz="1600" b="1" dirty="0">
                 <a:solidFill>
                   <a:srgbClr val="0B2545"/>
                 </a:solidFill>
@@ -3909,22 +4332,22 @@
                 <a:ea typeface="Trebuchet MS" pitchFamily="34" charset="-122"/>
                 <a:cs typeface="Trebuchet MS" pitchFamily="34" charset="-120"/>
               </a:rPr>
-              <a:t>Automated safety net</a:t>
-            </a:r>
-            <a:endParaRPr lang="en-US" sz="1700" dirty="0"/>
-          </a:p>
-        </p:txBody>
-      </p:sp>
-      <p:sp>
-        <p:nvSpPr>
-          <p:cNvPr id="24" name="Text 18"/>
-          <p:cNvSpPr/>
-          <p:nvPr/>
-        </p:nvSpPr>
-        <p:spPr>
-          <a:xfrm>
-            <a:off x="7511796" y="4370832"/>
-            <a:ext cx="3899916" cy="960120"/>
+              <a:t>Reproducible pipeline / notebook</a:t>
+            </a:r>
+            <a:endParaRPr lang="en-US" sz="1600" dirty="0"/>
+          </a:p>
+        </p:txBody>
+      </p:sp>
+      <p:sp>
+        <p:nvSpPr>
+          <p:cNvPr id="28" name="Text 22"/>
+          <p:cNvSpPr/>
+          <p:nvPr/>
+        </p:nvSpPr>
+        <p:spPr>
+          <a:xfrm>
+            <a:off x="7466076" y="4361688"/>
+            <a:ext cx="3945636" cy="777240"/>
           </a:xfrm>
           <a:prstGeom prst="rect">
             <a:avLst/>
@@ -3940,7 +4363,7 @@
               <a:buNone/>
             </a:pPr>
             <a:r>
-              <a:rPr lang="en-US" sz="1250" dirty="0">
+              <a:rPr lang="en-US" sz="1200" dirty="0">
                 <a:solidFill>
                   <a:srgbClr val="33495C"/>
                 </a:solidFill>
@@ -3948,73 +4371,22 @@
                 <a:ea typeface="Calibri" pitchFamily="34" charset="-122"/>
                 <a:cs typeface="Calibri" pitchFamily="34" charset="-120"/>
               </a:rPr>
-              <a:t>The scripted --test harness + CI conformance gate agent-generated code by tests, not trust.</a:t>
-            </a:r>
-            <a:endParaRPr lang="en-US" sz="1250" dirty="0"/>
-          </a:p>
-        </p:txBody>
-      </p:sp>
-      <p:sp>
-        <p:nvSpPr>
-          <p:cNvPr id="25" name="Shape 19"/>
-          <p:cNvSpPr/>
-          <p:nvPr/>
-        </p:nvSpPr>
-        <p:spPr>
-          <a:xfrm>
-            <a:off x="548640" y="5715000"/>
-            <a:ext cx="11091672" cy="566928"/>
-          </a:xfrm>
-          <a:prstGeom prst="roundRect">
-            <a:avLst>
-              <a:gd name="adj" fmla="val 9677"/>
-            </a:avLst>
-          </a:prstGeom>
-          <a:solidFill>
-            <a:srgbClr val="E8F1F4"/>
-          </a:solidFill>
-          <a:ln w="12700">
-            <a:solidFill>
-              <a:srgbClr val="C9DEE4"/>
-            </a:solidFill>
-            <a:prstDash val="solid"/>
-          </a:ln>
-        </p:spPr>
-      </p:sp>
-      <p:pic>
-        <p:nvPicPr>
-          <p:cNvPr id="26" name="Image 4" descr="preencoded.png">    </p:cNvPr>
-          <p:cNvPicPr>
-            <a:picLocks noChangeAspect="1"/>
-          </p:cNvPicPr>
-          <p:nvPr/>
-        </p:nvPicPr>
-        <p:blipFill>
-          <a:blip r:embed="rId5"/>
-          <a:stretch>
-            <a:fillRect/>
-          </a:stretch>
-        </p:blipFill>
-        <p:spPr>
-          <a:xfrm>
-            <a:off x="749808" y="5870448"/>
-            <a:ext cx="256032" cy="256032"/>
-          </a:xfrm>
-          <a:prstGeom prst="rect">
-            <a:avLst/>
-          </a:prstGeom>
-        </p:spPr>
-      </p:pic>
-      <p:sp>
-        <p:nvSpPr>
-          <p:cNvPr id="27" name="Text 20"/>
-          <p:cNvSpPr/>
-          <p:nvPr/>
-        </p:nvSpPr>
-        <p:spPr>
-          <a:xfrm>
-            <a:off x="1115568" y="5715000"/>
-            <a:ext cx="10360152" cy="566928"/>
+              <a:t>Drive ITK-SNAP from Python or an agent in a versioned, reproducible pipeline.</a:t>
+            </a:r>
+            <a:endParaRPr lang="en-US" sz="1200" dirty="0"/>
+          </a:p>
+        </p:txBody>
+      </p:sp>
+      <p:sp>
+        <p:nvSpPr>
+          <p:cNvPr id="29" name="Text 23"/>
+          <p:cNvSpPr/>
+          <p:nvPr/>
+        </p:nvSpPr>
+        <p:spPr>
+          <a:xfrm>
+            <a:off x="7466076" y="5029200"/>
+            <a:ext cx="3945636" cy="274320"/>
           </a:xfrm>
           <a:prstGeom prst="rect">
             <a:avLst/>
@@ -4030,53 +4402,53 @@
               <a:buNone/>
             </a:pPr>
             <a:r>
-              <a:rPr lang="en-US" sz="1250" b="1" dirty="0">
+              <a:rPr lang="en-US" sz="1050" b="1" dirty="0">
                 <a:solidFill>
                   <a:srgbClr val="13678A"/>
+                </a:solidFill>
+                <a:latin typeface="Trebuchet MS" pitchFamily="34" charset="0"/>
+                <a:ea typeface="Trebuchet MS" pitchFamily="34" charset="-122"/>
+                <a:cs typeface="Trebuchet MS" pitchFamily="34" charset="-120"/>
+              </a:rPr>
+              <a:t>Aims 1.1–1.2</a:t>
+            </a:r>
+            <a:endParaRPr lang="en-US" sz="1050" dirty="0"/>
+          </a:p>
+        </p:txBody>
+      </p:sp>
+      <p:sp>
+        <p:nvSpPr>
+          <p:cNvPr id="30" name="Text 24"/>
+          <p:cNvSpPr/>
+          <p:nvPr/>
+        </p:nvSpPr>
+        <p:spPr>
+          <a:xfrm>
+            <a:off x="548640" y="6446520"/>
+            <a:ext cx="8229600" cy="274320"/>
+          </a:xfrm>
+          <a:prstGeom prst="rect">
+            <a:avLst/>
+          </a:prstGeom>
+          <a:noFill/>
+          <a:ln/>
+        </p:spPr>
+        <p:txBody>
+          <a:bodyPr wrap="square" lIns="0" tIns="0" rIns="0" bIns="0" rtlCol="0" anchor="ctr"/>
+          <a:lstStyle/>
+          <a:p>
+            <a:pPr indent="0" marL="0">
+              <a:buNone/>
+            </a:pPr>
+            <a:r>
+              <a:rPr lang="en-US" sz="900" dirty="0">
+                <a:solidFill>
+                  <a:srgbClr val="6B7B8C"/>
                 </a:solidFill>
                 <a:latin typeface="Calibri" pitchFamily="34" charset="0"/>
                 <a:ea typeface="Calibri" pitchFamily="34" charset="-122"/>
                 <a:cs typeface="Calibri" pitchFamily="34" charset="-120"/>
               </a:rPr>
-              <a:t>Anchored on shipped, adopted code — a mature project, not a prototype or a rewrite.</a:t>
-            </a:r>
-            <a:endParaRPr lang="en-US" sz="1250" dirty="0"/>
-          </a:p>
-        </p:txBody>
-      </p:sp>
-      <p:sp>
-        <p:nvSpPr>
-          <p:cNvPr id="28" name="Text 21"/>
-          <p:cNvSpPr/>
-          <p:nvPr/>
-        </p:nvSpPr>
-        <p:spPr>
-          <a:xfrm>
-            <a:off x="548640" y="6446520"/>
-            <a:ext cx="8229600" cy="274320"/>
-          </a:xfrm>
-          <a:prstGeom prst="rect">
-            <a:avLst/>
-          </a:prstGeom>
-          <a:noFill/>
-          <a:ln/>
-        </p:spPr>
-        <p:txBody>
-          <a:bodyPr wrap="square" lIns="0" tIns="0" rIns="0" bIns="0" rtlCol="0" anchor="ctr"/>
-          <a:lstStyle/>
-          <a:p>
-            <a:pPr indent="0" marL="0">
-              <a:buNone/>
-            </a:pPr>
-            <a:r>
-              <a:rPr lang="en-US" sz="900" dirty="0">
-                <a:solidFill>
-                  <a:srgbClr val="6B7B8C"/>
-                </a:solidFill>
-                <a:latin typeface="Calibri" pitchFamily="34" charset="0"/>
-                <a:ea typeface="Calibri" pitchFamily="34" charset="-122"/>
-                <a:cs typeface="Calibri" pitchFamily="34" charset="-120"/>
-              </a:rPr>
               <a:t>OS4LS 2026  ·  ITK-SNAP AI-Native, Human-in-the-Loop Segmentation</a:t>
             </a:r>
             <a:endParaRPr lang="en-US" sz="900" dirty="0"/>
@@ -4085,7 +4457,7 @@
       </p:sp>
       <p:sp>
         <p:nvSpPr>
-          <p:cNvPr id="29" name="Text 22"/>
+          <p:cNvPr id="31" name="Text 25"/>
           <p:cNvSpPr/>
           <p:nvPr/>
         </p:nvSpPr>
@@ -4207,6 +4579,2982 @@
                 <a:ea typeface="Trebuchet MS" pitchFamily="34" charset="-122"/>
                 <a:cs typeface="Trebuchet MS" pitchFamily="34" charset="-120"/>
               </a:rPr>
+              <a:t>TECHNICAL FEASIBILITY</a:t>
+            </a:r>
+            <a:endParaRPr lang="en-US" sz="1300" dirty="0"/>
+          </a:p>
+        </p:txBody>
+      </p:sp>
+      <p:sp>
+        <p:nvSpPr>
+          <p:cNvPr id="4" name="Text 2"/>
+          <p:cNvSpPr/>
+          <p:nvPr/>
+        </p:nvSpPr>
+        <p:spPr>
+          <a:xfrm>
+            <a:off x="804672" y="658368"/>
+            <a:ext cx="11155680" cy="566928"/>
+          </a:xfrm>
+          <a:prstGeom prst="rect">
+            <a:avLst/>
+          </a:prstGeom>
+          <a:noFill/>
+          <a:ln/>
+        </p:spPr>
+        <p:txBody>
+          <a:bodyPr wrap="square" lIns="0" tIns="0" rIns="0" bIns="0" rtlCol="0" anchor="ctr"/>
+          <a:lstStyle/>
+          <a:p>
+            <a:pPr indent="0" marL="0">
+              <a:buNone/>
+            </a:pPr>
+            <a:r>
+              <a:rPr lang="en-US" sz="2700" b="1" dirty="0">
+                <a:solidFill>
+                  <a:srgbClr val="0B2545"/>
+                </a:solidFill>
+                <a:latin typeface="Trebuchet MS" pitchFamily="34" charset="0"/>
+                <a:ea typeface="Trebuchet MS" pitchFamily="34" charset="-122"/>
+                <a:cs typeface="Trebuchet MS" pitchFamily="34" charset="-120"/>
+              </a:rPr>
+              <a:t>Built on what already ships</a:t>
+            </a:r>
+            <a:endParaRPr lang="en-US" sz="2700" dirty="0"/>
+          </a:p>
+        </p:txBody>
+      </p:sp>
+      <p:sp>
+        <p:nvSpPr>
+          <p:cNvPr id="5" name="Text 3"/>
+          <p:cNvSpPr/>
+          <p:nvPr/>
+        </p:nvSpPr>
+        <p:spPr>
+          <a:xfrm>
+            <a:off x="804672" y="1261872"/>
+            <a:ext cx="11155680" cy="365760"/>
+          </a:xfrm>
+          <a:prstGeom prst="rect">
+            <a:avLst/>
+          </a:prstGeom>
+          <a:noFill/>
+          <a:ln/>
+        </p:spPr>
+        <p:txBody>
+          <a:bodyPr wrap="square" lIns="0" tIns="0" rIns="0" bIns="0" rtlCol="0" anchor="ctr"/>
+          <a:lstStyle/>
+          <a:p>
+            <a:pPr indent="0" marL="0">
+              <a:buNone/>
+            </a:pPr>
+            <a:r>
+              <a:rPr lang="en-US" sz="1400" i="1" dirty="0">
+                <a:solidFill>
+                  <a:srgbClr val="33495C"/>
+                </a:solidFill>
+                <a:latin typeface="Calibri" pitchFamily="34" charset="0"/>
+                <a:ea typeface="Calibri" pitchFamily="34" charset="-122"/>
+                <a:cs typeface="Calibri" pitchFamily="34" charset="-120"/>
+              </a:rPr>
+              <a:t>Most of Aims 1–4 extends existing, working components — not new subsystems.</a:t>
+            </a:r>
+            <a:endParaRPr lang="en-US" sz="1400" dirty="0"/>
+          </a:p>
+        </p:txBody>
+      </p:sp>
+      <p:sp>
+        <p:nvSpPr>
+          <p:cNvPr id="6" name="Shape 4"/>
+          <p:cNvSpPr/>
+          <p:nvPr/>
+        </p:nvSpPr>
+        <p:spPr>
+          <a:xfrm>
+            <a:off x="548640" y="1828800"/>
+            <a:ext cx="5362956" cy="749808"/>
+          </a:xfrm>
+          <a:prstGeom prst="roundRect">
+            <a:avLst>
+              <a:gd name="adj" fmla="val 7317"/>
+            </a:avLst>
+          </a:prstGeom>
+          <a:solidFill>
+            <a:srgbClr val="FFFFFF"/>
+          </a:solidFill>
+          <a:ln w="12700">
+            <a:solidFill>
+              <a:srgbClr val="DCE5EF"/>
+            </a:solidFill>
+            <a:prstDash val="solid"/>
+          </a:ln>
+          <a:effectLst>
+            <a:outerShdw sx="100000" sy="100000" kx="0" ky="0" algn="bl" rotWithShape="0" blurRad="114300" dist="38100" dir="5400000">
+              <a:srgbClr val="0B2545">
+                <a:alpha val="16000"/>
+              </a:srgbClr>
+            </a:outerShdw>
+          </a:effectLst>
+        </p:spPr>
+      </p:sp>
+      <p:sp>
+        <p:nvSpPr>
+          <p:cNvPr id="7" name="Shape 5"/>
+          <p:cNvSpPr/>
+          <p:nvPr/>
+        </p:nvSpPr>
+        <p:spPr>
+          <a:xfrm>
+            <a:off x="548640" y="1828800"/>
+            <a:ext cx="91440" cy="749808"/>
+          </a:xfrm>
+          <a:prstGeom prst="rect">
+            <a:avLst/>
+          </a:prstGeom>
+          <a:solidFill>
+            <a:srgbClr val="1496A6"/>
+          </a:solidFill>
+          <a:ln/>
+        </p:spPr>
+      </p:sp>
+      <p:pic>
+        <p:nvPicPr>
+          <p:cNvPr id="8" name="Image 0" descr="preencoded.png">    </p:cNvPr>
+          <p:cNvPicPr>
+            <a:picLocks noChangeAspect="1"/>
+          </p:cNvPicPr>
+          <p:nvPr/>
+        </p:nvPicPr>
+        <p:blipFill>
+          <a:blip r:embed="rId1"/>
+          <a:stretch>
+            <a:fillRect/>
+          </a:stretch>
+        </p:blipFill>
+        <p:spPr>
+          <a:xfrm>
+            <a:off x="804672" y="2057400"/>
+            <a:ext cx="292608" cy="292608"/>
+          </a:xfrm>
+          <a:prstGeom prst="rect">
+            <a:avLst/>
+          </a:prstGeom>
+        </p:spPr>
+      </p:pic>
+      <p:sp>
+        <p:nvSpPr>
+          <p:cNvPr id="9" name="Text 6"/>
+          <p:cNvSpPr/>
+          <p:nvPr/>
+        </p:nvSpPr>
+        <p:spPr>
+          <a:xfrm>
+            <a:off x="1207008" y="1828800"/>
+            <a:ext cx="4539996" cy="749808"/>
+          </a:xfrm>
+          <a:prstGeom prst="rect">
+            <a:avLst/>
+          </a:prstGeom>
+          <a:noFill/>
+          <a:ln/>
+        </p:spPr>
+        <p:txBody>
+          <a:bodyPr wrap="square" lIns="0" tIns="0" rIns="0" bIns="0" rtlCol="0" anchor="ctr"/>
+          <a:lstStyle/>
+          <a:p>
+            <a:pPr indent="0" marL="0">
+              <a:buNone/>
+            </a:pPr>
+            <a:r>
+              <a:rPr lang="en-US" sz="1200" b="1" dirty="0">
+                <a:solidFill>
+                  <a:srgbClr val="0B2545"/>
+                </a:solidFill>
+                <a:latin typeface="Trebuchet MS" pitchFamily="34" charset="0"/>
+                <a:ea typeface="Trebuchet MS" pitchFamily="34" charset="-122"/>
+                <a:cs typeface="Trebuchet MS" pitchFamily="34" charset="-120"/>
+              </a:rPr>
+              <a:t>Programmable workspaces, labels, display  </a:t>
+            </a:r>
+            <a:pPr indent="0" marL="0">
+              <a:buNone/>
+            </a:pPr>
+            <a:r>
+              <a:rPr lang="en-US" sz="1200" dirty="0">
+                <a:solidFill>
+                  <a:srgbClr val="13678A"/>
+                </a:solidFill>
+                <a:latin typeface="Calibri" pitchFamily="34" charset="0"/>
+                <a:ea typeface="Calibri" pitchFamily="34" charset="-122"/>
+                <a:cs typeface="Calibri" pitchFamily="34" charset="-120"/>
+              </a:rPr>
+              <a:t>→ Logic/WorkspaceAPI</a:t>
+            </a:r>
+            <a:endParaRPr lang="en-US" sz="1200" dirty="0"/>
+          </a:p>
+        </p:txBody>
+      </p:sp>
+      <p:sp>
+        <p:nvSpPr>
+          <p:cNvPr id="10" name="Shape 7"/>
+          <p:cNvSpPr/>
+          <p:nvPr/>
+        </p:nvSpPr>
+        <p:spPr>
+          <a:xfrm>
+            <a:off x="6277356" y="1828800"/>
+            <a:ext cx="5362956" cy="749808"/>
+          </a:xfrm>
+          <a:prstGeom prst="roundRect">
+            <a:avLst>
+              <a:gd name="adj" fmla="val 7317"/>
+            </a:avLst>
+          </a:prstGeom>
+          <a:solidFill>
+            <a:srgbClr val="FFFFFF"/>
+          </a:solidFill>
+          <a:ln w="12700">
+            <a:solidFill>
+              <a:srgbClr val="DCE5EF"/>
+            </a:solidFill>
+            <a:prstDash val="solid"/>
+          </a:ln>
+          <a:effectLst>
+            <a:outerShdw sx="100000" sy="100000" kx="0" ky="0" algn="bl" rotWithShape="0" blurRad="114300" dist="38100" dir="5400000">
+              <a:srgbClr val="0B2545">
+                <a:alpha val="16000"/>
+              </a:srgbClr>
+            </a:outerShdw>
+          </a:effectLst>
+        </p:spPr>
+      </p:sp>
+      <p:sp>
+        <p:nvSpPr>
+          <p:cNvPr id="11" name="Shape 8"/>
+          <p:cNvSpPr/>
+          <p:nvPr/>
+        </p:nvSpPr>
+        <p:spPr>
+          <a:xfrm>
+            <a:off x="6277356" y="1828800"/>
+            <a:ext cx="91440" cy="749808"/>
+          </a:xfrm>
+          <a:prstGeom prst="rect">
+            <a:avLst/>
+          </a:prstGeom>
+          <a:solidFill>
+            <a:srgbClr val="1496A6"/>
+          </a:solidFill>
+          <a:ln/>
+        </p:spPr>
+      </p:sp>
+      <p:pic>
+        <p:nvPicPr>
+          <p:cNvPr id="12" name="Image 1" descr="preencoded.png">    </p:cNvPr>
+          <p:cNvPicPr>
+            <a:picLocks noChangeAspect="1"/>
+          </p:cNvPicPr>
+          <p:nvPr/>
+        </p:nvPicPr>
+        <p:blipFill>
+          <a:blip r:embed="rId2"/>
+          <a:stretch>
+            <a:fillRect/>
+          </a:stretch>
+        </p:blipFill>
+        <p:spPr>
+          <a:xfrm>
+            <a:off x="6533388" y="2057400"/>
+            <a:ext cx="292608" cy="292608"/>
+          </a:xfrm>
+          <a:prstGeom prst="rect">
+            <a:avLst/>
+          </a:prstGeom>
+        </p:spPr>
+      </p:pic>
+      <p:sp>
+        <p:nvSpPr>
+          <p:cNvPr id="13" name="Text 9"/>
+          <p:cNvSpPr/>
+          <p:nvPr/>
+        </p:nvSpPr>
+        <p:spPr>
+          <a:xfrm>
+            <a:off x="6935724" y="1828800"/>
+            <a:ext cx="4539996" cy="749808"/>
+          </a:xfrm>
+          <a:prstGeom prst="rect">
+            <a:avLst/>
+          </a:prstGeom>
+          <a:noFill/>
+          <a:ln/>
+        </p:spPr>
+        <p:txBody>
+          <a:bodyPr wrap="square" lIns="0" tIns="0" rIns="0" bIns="0" rtlCol="0" anchor="ctr"/>
+          <a:lstStyle/>
+          <a:p>
+            <a:pPr indent="0" marL="0">
+              <a:buNone/>
+            </a:pPr>
+            <a:r>
+              <a:rPr lang="en-US" sz="1200" b="1" dirty="0">
+                <a:solidFill>
+                  <a:srgbClr val="0B2545"/>
+                </a:solidFill>
+                <a:latin typeface="Trebuchet MS" pitchFamily="34" charset="0"/>
+                <a:ea typeface="Trebuchet MS" pitchFamily="34" charset="-122"/>
+                <a:cs typeface="Trebuchet MS" pitchFamily="34" charset="-120"/>
+              </a:rPr>
+              <a:t>Headless operation today  </a:t>
+            </a:r>
+            <a:pPr indent="0" marL="0">
+              <a:buNone/>
+            </a:pPr>
+            <a:r>
+              <a:rPr lang="en-US" sz="1200" dirty="0">
+                <a:solidFill>
+                  <a:srgbClr val="13678A"/>
+                </a:solidFill>
+                <a:latin typeface="Calibri" pitchFamily="34" charset="0"/>
+                <a:ea typeface="Calibri" pitchFamily="34" charset="-122"/>
+                <a:cs typeface="Calibri" pitchFamily="34" charset="-120"/>
+              </a:rPr>
+              <a:t>→ itksnap-wt CLI</a:t>
+            </a:r>
+            <a:endParaRPr lang="en-US" sz="1200" dirty="0"/>
+          </a:p>
+        </p:txBody>
+      </p:sp>
+      <p:sp>
+        <p:nvSpPr>
+          <p:cNvPr id="14" name="Shape 10"/>
+          <p:cNvSpPr/>
+          <p:nvPr/>
+        </p:nvSpPr>
+        <p:spPr>
+          <a:xfrm>
+            <a:off x="548640" y="2724912"/>
+            <a:ext cx="5362956" cy="749808"/>
+          </a:xfrm>
+          <a:prstGeom prst="roundRect">
+            <a:avLst>
+              <a:gd name="adj" fmla="val 7317"/>
+            </a:avLst>
+          </a:prstGeom>
+          <a:solidFill>
+            <a:srgbClr val="FFFFFF"/>
+          </a:solidFill>
+          <a:ln w="12700">
+            <a:solidFill>
+              <a:srgbClr val="DCE5EF"/>
+            </a:solidFill>
+            <a:prstDash val="solid"/>
+          </a:ln>
+          <a:effectLst>
+            <a:outerShdw sx="100000" sy="100000" kx="0" ky="0" algn="bl" rotWithShape="0" blurRad="114300" dist="38100" dir="5400000">
+              <a:srgbClr val="0B2545">
+                <a:alpha val="16000"/>
+              </a:srgbClr>
+            </a:outerShdw>
+          </a:effectLst>
+        </p:spPr>
+      </p:sp>
+      <p:sp>
+        <p:nvSpPr>
+          <p:cNvPr id="15" name="Shape 11"/>
+          <p:cNvSpPr/>
+          <p:nvPr/>
+        </p:nvSpPr>
+        <p:spPr>
+          <a:xfrm>
+            <a:off x="548640" y="2724912"/>
+            <a:ext cx="91440" cy="749808"/>
+          </a:xfrm>
+          <a:prstGeom prst="rect">
+            <a:avLst/>
+          </a:prstGeom>
+          <a:solidFill>
+            <a:srgbClr val="1496A6"/>
+          </a:solidFill>
+          <a:ln/>
+        </p:spPr>
+      </p:sp>
+      <p:pic>
+        <p:nvPicPr>
+          <p:cNvPr id="16" name="Image 2" descr="preencoded.png">    </p:cNvPr>
+          <p:cNvPicPr>
+            <a:picLocks noChangeAspect="1"/>
+          </p:cNvPicPr>
+          <p:nvPr/>
+        </p:nvPicPr>
+        <p:blipFill>
+          <a:blip r:embed="rId3"/>
+          <a:stretch>
+            <a:fillRect/>
+          </a:stretch>
+        </p:blipFill>
+        <p:spPr>
+          <a:xfrm>
+            <a:off x="804672" y="2953512"/>
+            <a:ext cx="292608" cy="292608"/>
+          </a:xfrm>
+          <a:prstGeom prst="rect">
+            <a:avLst/>
+          </a:prstGeom>
+        </p:spPr>
+      </p:pic>
+      <p:sp>
+        <p:nvSpPr>
+          <p:cNvPr id="17" name="Text 12"/>
+          <p:cNvSpPr/>
+          <p:nvPr/>
+        </p:nvSpPr>
+        <p:spPr>
+          <a:xfrm>
+            <a:off x="1207008" y="2724912"/>
+            <a:ext cx="4539996" cy="749808"/>
+          </a:xfrm>
+          <a:prstGeom prst="rect">
+            <a:avLst/>
+          </a:prstGeom>
+          <a:noFill/>
+          <a:ln/>
+        </p:spPr>
+        <p:txBody>
+          <a:bodyPr wrap="square" lIns="0" tIns="0" rIns="0" bIns="0" rtlCol="0" anchor="ctr"/>
+          <a:lstStyle/>
+          <a:p>
+            <a:pPr indent="0" marL="0">
+              <a:buNone/>
+            </a:pPr>
+            <a:r>
+              <a:rPr lang="en-US" sz="1200" b="1" dirty="0">
+                <a:solidFill>
+                  <a:srgbClr val="0B2545"/>
+                </a:solidFill>
+                <a:latin typeface="Trebuchet MS" pitchFamily="34" charset="0"/>
+                <a:ea typeface="Trebuchet MS" pitchFamily="34" charset="-122"/>
+                <a:cs typeface="Trebuchet MS" pitchFamily="34" charset="-120"/>
+              </a:rPr>
+              <a:t>REST + SSH transport  </a:t>
+            </a:r>
+            <a:pPr indent="0" marL="0">
+              <a:buNone/>
+            </a:pPr>
+            <a:r>
+              <a:rPr lang="en-US" sz="1200" dirty="0">
+                <a:solidFill>
+                  <a:srgbClr val="13678A"/>
+                </a:solidFill>
+                <a:latin typeface="Calibri" pitchFamily="34" charset="0"/>
+                <a:ea typeface="Calibri" pitchFamily="34" charset="-122"/>
+                <a:cs typeface="Calibri" pitchFamily="34" charset="-120"/>
+              </a:rPr>
+              <a:t>→ RESTClient · SSHTunnel</a:t>
+            </a:r>
+            <a:endParaRPr lang="en-US" sz="1200" dirty="0"/>
+          </a:p>
+        </p:txBody>
+      </p:sp>
+      <p:sp>
+        <p:nvSpPr>
+          <p:cNvPr id="18" name="Shape 13"/>
+          <p:cNvSpPr/>
+          <p:nvPr/>
+        </p:nvSpPr>
+        <p:spPr>
+          <a:xfrm>
+            <a:off x="6277356" y="2724912"/>
+            <a:ext cx="5362956" cy="749808"/>
+          </a:xfrm>
+          <a:prstGeom prst="roundRect">
+            <a:avLst>
+              <a:gd name="adj" fmla="val 7317"/>
+            </a:avLst>
+          </a:prstGeom>
+          <a:solidFill>
+            <a:srgbClr val="FFFFFF"/>
+          </a:solidFill>
+          <a:ln w="12700">
+            <a:solidFill>
+              <a:srgbClr val="DCE5EF"/>
+            </a:solidFill>
+            <a:prstDash val="solid"/>
+          </a:ln>
+          <a:effectLst>
+            <a:outerShdw sx="100000" sy="100000" kx="0" ky="0" algn="bl" rotWithShape="0" blurRad="114300" dist="38100" dir="5400000">
+              <a:srgbClr val="0B2545">
+                <a:alpha val="16000"/>
+              </a:srgbClr>
+            </a:outerShdw>
+          </a:effectLst>
+        </p:spPr>
+      </p:sp>
+      <p:sp>
+        <p:nvSpPr>
+          <p:cNvPr id="19" name="Shape 14"/>
+          <p:cNvSpPr/>
+          <p:nvPr/>
+        </p:nvSpPr>
+        <p:spPr>
+          <a:xfrm>
+            <a:off x="6277356" y="2724912"/>
+            <a:ext cx="91440" cy="749808"/>
+          </a:xfrm>
+          <a:prstGeom prst="rect">
+            <a:avLst/>
+          </a:prstGeom>
+          <a:solidFill>
+            <a:srgbClr val="1496A6"/>
+          </a:solidFill>
+          <a:ln/>
+        </p:spPr>
+      </p:sp>
+      <p:pic>
+        <p:nvPicPr>
+          <p:cNvPr id="20" name="Image 3" descr="preencoded.png">    </p:cNvPr>
+          <p:cNvPicPr>
+            <a:picLocks noChangeAspect="1"/>
+          </p:cNvPicPr>
+          <p:nvPr/>
+        </p:nvPicPr>
+        <p:blipFill>
+          <a:blip r:embed="rId4"/>
+          <a:stretch>
+            <a:fillRect/>
+          </a:stretch>
+        </p:blipFill>
+        <p:spPr>
+          <a:xfrm>
+            <a:off x="6533388" y="2953512"/>
+            <a:ext cx="292608" cy="292608"/>
+          </a:xfrm>
+          <a:prstGeom prst="rect">
+            <a:avLst/>
+          </a:prstGeom>
+        </p:spPr>
+      </p:pic>
+      <p:sp>
+        <p:nvSpPr>
+          <p:cNvPr id="21" name="Text 15"/>
+          <p:cNvSpPr/>
+          <p:nvPr/>
+        </p:nvSpPr>
+        <p:spPr>
+          <a:xfrm>
+            <a:off x="6935724" y="2724912"/>
+            <a:ext cx="4539996" cy="749808"/>
+          </a:xfrm>
+          <a:prstGeom prst="rect">
+            <a:avLst/>
+          </a:prstGeom>
+          <a:noFill/>
+          <a:ln/>
+        </p:spPr>
+        <p:txBody>
+          <a:bodyPr wrap="square" lIns="0" tIns="0" rIns="0" bIns="0" rtlCol="0" anchor="ctr"/>
+          <a:lstStyle/>
+          <a:p>
+            <a:pPr indent="0" marL="0">
+              <a:buNone/>
+            </a:pPr>
+            <a:r>
+              <a:rPr lang="en-US" sz="1200" b="1" dirty="0">
+                <a:solidFill>
+                  <a:srgbClr val="0B2545"/>
+                </a:solidFill>
+                <a:latin typeface="Trebuchet MS" pitchFamily="34" charset="0"/>
+                <a:ea typeface="Trebuchet MS" pitchFamily="34" charset="-122"/>
+                <a:cs typeface="Trebuchet MS" pitchFamily="34" charset="-120"/>
+              </a:rPr>
+              <a:t>DL-server client (local / remote / SSH)  </a:t>
+            </a:r>
+            <a:pPr indent="0" marL="0">
+              <a:buNone/>
+            </a:pPr>
+            <a:r>
+              <a:rPr lang="en-US" sz="1200" dirty="0">
+                <a:solidFill>
+                  <a:srgbClr val="13678A"/>
+                </a:solidFill>
+                <a:latin typeface="Calibri" pitchFamily="34" charset="0"/>
+                <a:ea typeface="Calibri" pitchFamily="34" charset="-122"/>
+                <a:cs typeface="Calibri" pitchFamily="34" charset="-120"/>
+              </a:rPr>
+              <a:t>→ DeepLearningSegmentationModel</a:t>
+            </a:r>
+            <a:endParaRPr lang="en-US" sz="1200" dirty="0"/>
+          </a:p>
+        </p:txBody>
+      </p:sp>
+      <p:sp>
+        <p:nvSpPr>
+          <p:cNvPr id="22" name="Shape 16"/>
+          <p:cNvSpPr/>
+          <p:nvPr/>
+        </p:nvSpPr>
+        <p:spPr>
+          <a:xfrm>
+            <a:off x="548640" y="3621024"/>
+            <a:ext cx="5362956" cy="749808"/>
+          </a:xfrm>
+          <a:prstGeom prst="roundRect">
+            <a:avLst>
+              <a:gd name="adj" fmla="val 7317"/>
+            </a:avLst>
+          </a:prstGeom>
+          <a:solidFill>
+            <a:srgbClr val="FFFFFF"/>
+          </a:solidFill>
+          <a:ln w="12700">
+            <a:solidFill>
+              <a:srgbClr val="DCE5EF"/>
+            </a:solidFill>
+            <a:prstDash val="solid"/>
+          </a:ln>
+          <a:effectLst>
+            <a:outerShdw sx="100000" sy="100000" kx="0" ky="0" algn="bl" rotWithShape="0" blurRad="114300" dist="38100" dir="5400000">
+              <a:srgbClr val="0B2545">
+                <a:alpha val="16000"/>
+              </a:srgbClr>
+            </a:outerShdw>
+          </a:effectLst>
+        </p:spPr>
+      </p:sp>
+      <p:sp>
+        <p:nvSpPr>
+          <p:cNvPr id="23" name="Shape 17"/>
+          <p:cNvSpPr/>
+          <p:nvPr/>
+        </p:nvSpPr>
+        <p:spPr>
+          <a:xfrm>
+            <a:off x="548640" y="3621024"/>
+            <a:ext cx="91440" cy="749808"/>
+          </a:xfrm>
+          <a:prstGeom prst="rect">
+            <a:avLst/>
+          </a:prstGeom>
+          <a:solidFill>
+            <a:srgbClr val="1496A6"/>
+          </a:solidFill>
+          <a:ln/>
+        </p:spPr>
+      </p:sp>
+      <p:pic>
+        <p:nvPicPr>
+          <p:cNvPr id="24" name="Image 4" descr="preencoded.png">    </p:cNvPr>
+          <p:cNvPicPr>
+            <a:picLocks noChangeAspect="1"/>
+          </p:cNvPicPr>
+          <p:nvPr/>
+        </p:nvPicPr>
+        <p:blipFill>
+          <a:blip r:embed="rId5"/>
+          <a:stretch>
+            <a:fillRect/>
+          </a:stretch>
+        </p:blipFill>
+        <p:spPr>
+          <a:xfrm>
+            <a:off x="804672" y="3849624"/>
+            <a:ext cx="292608" cy="292608"/>
+          </a:xfrm>
+          <a:prstGeom prst="rect">
+            <a:avLst/>
+          </a:prstGeom>
+        </p:spPr>
+      </p:pic>
+      <p:sp>
+        <p:nvSpPr>
+          <p:cNvPr id="25" name="Text 18"/>
+          <p:cNvSpPr/>
+          <p:nvPr/>
+        </p:nvSpPr>
+        <p:spPr>
+          <a:xfrm>
+            <a:off x="1207008" y="3621024"/>
+            <a:ext cx="4539996" cy="749808"/>
+          </a:xfrm>
+          <a:prstGeom prst="rect">
+            <a:avLst/>
+          </a:prstGeom>
+          <a:noFill/>
+          <a:ln/>
+        </p:spPr>
+        <p:txBody>
+          <a:bodyPr wrap="square" lIns="0" tIns="0" rIns="0" bIns="0" rtlCol="0" anchor="ctr"/>
+          <a:lstStyle/>
+          <a:p>
+            <a:pPr indent="0" marL="0">
+              <a:buNone/>
+            </a:pPr>
+            <a:r>
+              <a:rPr lang="en-US" sz="1200" b="1" dirty="0">
+                <a:solidFill>
+                  <a:srgbClr val="0B2545"/>
+                </a:solidFill>
+                <a:latin typeface="Trebuchet MS" pitchFamily="34" charset="0"/>
+                <a:ea typeface="Trebuchet MS" pitchFamily="34" charset="-122"/>
+                <a:cs typeface="Trebuchet MS" pitchFamily="34" charset="-120"/>
+              </a:rPr>
+              <a:t>Async submit → await → return  </a:t>
+            </a:r>
+            <a:pPr indent="0" marL="0">
+              <a:buNone/>
+            </a:pPr>
+            <a:r>
+              <a:rPr lang="en-US" sz="1200" dirty="0">
+                <a:solidFill>
+                  <a:srgbClr val="13678A"/>
+                </a:solidFill>
+                <a:latin typeface="Calibri" pitchFamily="34" charset="0"/>
+                <a:ea typeface="Calibri" pitchFamily="34" charset="-122"/>
+                <a:cs typeface="Calibri" pitchFamily="34" charset="-120"/>
+              </a:rPr>
+              <a:t>→ DistributedSegmentationModel</a:t>
+            </a:r>
+            <a:endParaRPr lang="en-US" sz="1200" dirty="0"/>
+          </a:p>
+        </p:txBody>
+      </p:sp>
+      <p:sp>
+        <p:nvSpPr>
+          <p:cNvPr id="26" name="Shape 19"/>
+          <p:cNvSpPr/>
+          <p:nvPr/>
+        </p:nvSpPr>
+        <p:spPr>
+          <a:xfrm>
+            <a:off x="6277356" y="3621024"/>
+            <a:ext cx="5362956" cy="749808"/>
+          </a:xfrm>
+          <a:prstGeom prst="roundRect">
+            <a:avLst>
+              <a:gd name="adj" fmla="val 7317"/>
+            </a:avLst>
+          </a:prstGeom>
+          <a:solidFill>
+            <a:srgbClr val="FFFFFF"/>
+          </a:solidFill>
+          <a:ln w="12700">
+            <a:solidFill>
+              <a:srgbClr val="DCE5EF"/>
+            </a:solidFill>
+            <a:prstDash val="solid"/>
+          </a:ln>
+          <a:effectLst>
+            <a:outerShdw sx="100000" sy="100000" kx="0" ky="0" algn="bl" rotWithShape="0" blurRad="114300" dist="38100" dir="5400000">
+              <a:srgbClr val="0B2545">
+                <a:alpha val="16000"/>
+              </a:srgbClr>
+            </a:outerShdw>
+          </a:effectLst>
+        </p:spPr>
+      </p:sp>
+      <p:sp>
+        <p:nvSpPr>
+          <p:cNvPr id="27" name="Shape 20"/>
+          <p:cNvSpPr/>
+          <p:nvPr/>
+        </p:nvSpPr>
+        <p:spPr>
+          <a:xfrm>
+            <a:off x="6277356" y="3621024"/>
+            <a:ext cx="91440" cy="749808"/>
+          </a:xfrm>
+          <a:prstGeom prst="rect">
+            <a:avLst/>
+          </a:prstGeom>
+          <a:solidFill>
+            <a:srgbClr val="1496A6"/>
+          </a:solidFill>
+          <a:ln/>
+        </p:spPr>
+      </p:sp>
+      <p:pic>
+        <p:nvPicPr>
+          <p:cNvPr id="28" name="Image 5" descr="preencoded.png">    </p:cNvPr>
+          <p:cNvPicPr>
+            <a:picLocks noChangeAspect="1"/>
+          </p:cNvPicPr>
+          <p:nvPr/>
+        </p:nvPicPr>
+        <p:blipFill>
+          <a:blip r:embed="rId6"/>
+          <a:stretch>
+            <a:fillRect/>
+          </a:stretch>
+        </p:blipFill>
+        <p:spPr>
+          <a:xfrm>
+            <a:off x="6533388" y="3849624"/>
+            <a:ext cx="292608" cy="292608"/>
+          </a:xfrm>
+          <a:prstGeom prst="rect">
+            <a:avLst/>
+          </a:prstGeom>
+        </p:spPr>
+      </p:pic>
+      <p:sp>
+        <p:nvSpPr>
+          <p:cNvPr id="29" name="Text 21"/>
+          <p:cNvSpPr/>
+          <p:nvPr/>
+        </p:nvSpPr>
+        <p:spPr>
+          <a:xfrm>
+            <a:off x="6935724" y="3621024"/>
+            <a:ext cx="4539996" cy="749808"/>
+          </a:xfrm>
+          <a:prstGeom prst="rect">
+            <a:avLst/>
+          </a:prstGeom>
+          <a:noFill/>
+          <a:ln/>
+        </p:spPr>
+        <p:txBody>
+          <a:bodyPr wrap="square" lIns="0" tIns="0" rIns="0" bIns="0" rtlCol="0" anchor="ctr"/>
+          <a:lstStyle/>
+          <a:p>
+            <a:pPr indent="0" marL="0">
+              <a:buNone/>
+            </a:pPr>
+            <a:r>
+              <a:rPr lang="en-US" sz="1200" b="1" dirty="0">
+                <a:solidFill>
+                  <a:srgbClr val="0B2545"/>
+                </a:solidFill>
+                <a:latin typeface="Trebuchet MS" pitchFamily="34" charset="0"/>
+                <a:ea typeface="Trebuchet MS" pitchFamily="34" charset="-122"/>
+                <a:cs typeface="Trebuchet MS" pitchFamily="34" charset="-120"/>
+              </a:rPr>
+              <a:t>Python bindings toolchain  </a:t>
+            </a:r>
+            <a:pPr indent="0" marL="0">
+              <a:buNone/>
+            </a:pPr>
+            <a:r>
+              <a:rPr lang="en-US" sz="1200" dirty="0">
+                <a:solidFill>
+                  <a:srgbClr val="13678A"/>
+                </a:solidFill>
+                <a:latin typeface="Calibri" pitchFamily="34" charset="0"/>
+                <a:ea typeface="Calibri" pitchFamily="34" charset="-122"/>
+                <a:cs typeface="Calibri" pitchFamily="34" charset="-120"/>
+              </a:rPr>
+              <a:t>→ pybind11 · greedy_python</a:t>
+            </a:r>
+            <a:endParaRPr lang="en-US" sz="1200" dirty="0"/>
+          </a:p>
+        </p:txBody>
+      </p:sp>
+      <p:sp>
+        <p:nvSpPr>
+          <p:cNvPr id="30" name="Shape 22"/>
+          <p:cNvSpPr/>
+          <p:nvPr/>
+        </p:nvSpPr>
+        <p:spPr>
+          <a:xfrm>
+            <a:off x="548640" y="4709160"/>
+            <a:ext cx="11091672" cy="960120"/>
+          </a:xfrm>
+          <a:prstGeom prst="roundRect">
+            <a:avLst>
+              <a:gd name="adj" fmla="val 6667"/>
+            </a:avLst>
+          </a:prstGeom>
+          <a:solidFill>
+            <a:srgbClr val="0B2545"/>
+          </a:solidFill>
+          <a:ln/>
+          <a:effectLst>
+            <a:outerShdw sx="100000" sy="100000" kx="0" ky="0" algn="bl" rotWithShape="0" blurRad="114300" dist="38100" dir="5400000">
+              <a:srgbClr val="0B2545">
+                <a:alpha val="16000"/>
+              </a:srgbClr>
+            </a:outerShdw>
+          </a:effectLst>
+        </p:spPr>
+      </p:sp>
+      <p:sp>
+        <p:nvSpPr>
+          <p:cNvPr id="31" name="Text 23"/>
+          <p:cNvSpPr/>
+          <p:nvPr/>
+        </p:nvSpPr>
+        <p:spPr>
+          <a:xfrm>
+            <a:off x="868680" y="4709160"/>
+            <a:ext cx="10451592" cy="960120"/>
+          </a:xfrm>
+          <a:prstGeom prst="rect">
+            <a:avLst/>
+          </a:prstGeom>
+          <a:noFill/>
+          <a:ln/>
+        </p:spPr>
+        <p:txBody>
+          <a:bodyPr wrap="square" lIns="0" tIns="0" rIns="0" bIns="0" rtlCol="0" anchor="ctr"/>
+          <a:lstStyle/>
+          <a:p>
+            <a:pPr indent="0" marL="0">
+              <a:buNone/>
+            </a:pPr>
+            <a:r>
+              <a:rPr lang="en-US" sz="1350" b="1" dirty="0">
+                <a:solidFill>
+                  <a:srgbClr val="E8924A"/>
+                </a:solidFill>
+                <a:latin typeface="Calibri" pitchFamily="34" charset="0"/>
+                <a:ea typeface="Calibri" pitchFamily="34" charset="-122"/>
+                <a:cs typeface="Calibri" pitchFamily="34" charset="-120"/>
+              </a:rPr>
+              <a:t>~70–80% extends shipped components.  </a:t>
+            </a:r>
+            <a:pPr indent="0" marL="0">
+              <a:buNone/>
+            </a:pPr>
+            <a:r>
+              <a:rPr lang="en-US" sz="1350" dirty="0">
+                <a:solidFill>
+                  <a:srgbClr val="CADCFC"/>
+                </a:solidFill>
+                <a:latin typeface="Calibri" pitchFamily="34" charset="0"/>
+                <a:ea typeface="Calibri" pitchFamily="34" charset="-122"/>
+                <a:cs typeface="Calibri" pitchFamily="34" charset="-120"/>
+              </a:rPr>
+              <a:t>Even </a:t>
+            </a:r>
+            <a:pPr indent="0" marL="0">
+              <a:buNone/>
+            </a:pPr>
+            <a:r>
+              <a:rPr lang="en-US" sz="1350" b="1" dirty="0">
+                <a:solidFill>
+                  <a:srgbClr val="FFFFFF"/>
+                </a:solidFill>
+                <a:latin typeface="Calibri" pitchFamily="34" charset="0"/>
+                <a:ea typeface="Calibri" pitchFamily="34" charset="-122"/>
+                <a:cs typeface="Calibri" pitchFamily="34" charset="-120"/>
+              </a:rPr>
+              <a:t>request_review</a:t>
+            </a:r>
+            <a:pPr indent="0" marL="0">
+              <a:buNone/>
+            </a:pPr>
+            <a:r>
+              <a:rPr lang="en-US" sz="1350" dirty="0">
+                <a:solidFill>
+                  <a:srgbClr val="CADCFC"/>
+                </a:solidFill>
+                <a:latin typeface="Calibri" pitchFamily="34" charset="0"/>
+                <a:ea typeface="Calibri" pitchFamily="34" charset="-122"/>
+                <a:cs typeface="Calibri" pitchFamily="34" charset="-120"/>
+              </a:rPr>
+              <a:t> reuses the async ticket workflow already shipped in DistributedSegmentationModel — with a human as the “worker.”</a:t>
+            </a:r>
+            <a:endParaRPr lang="en-US" sz="1350" dirty="0"/>
+          </a:p>
+        </p:txBody>
+      </p:sp>
+      <p:sp>
+        <p:nvSpPr>
+          <p:cNvPr id="32" name="Text 24"/>
+          <p:cNvSpPr/>
+          <p:nvPr/>
+        </p:nvSpPr>
+        <p:spPr>
+          <a:xfrm>
+            <a:off x="548640" y="6446520"/>
+            <a:ext cx="8229600" cy="274320"/>
+          </a:xfrm>
+          <a:prstGeom prst="rect">
+            <a:avLst/>
+          </a:prstGeom>
+          <a:noFill/>
+          <a:ln/>
+        </p:spPr>
+        <p:txBody>
+          <a:bodyPr wrap="square" lIns="0" tIns="0" rIns="0" bIns="0" rtlCol="0" anchor="ctr"/>
+          <a:lstStyle/>
+          <a:p>
+            <a:pPr indent="0" marL="0">
+              <a:buNone/>
+            </a:pPr>
+            <a:r>
+              <a:rPr lang="en-US" sz="900" dirty="0">
+                <a:solidFill>
+                  <a:srgbClr val="6B7B8C"/>
+                </a:solidFill>
+                <a:latin typeface="Calibri" pitchFamily="34" charset="0"/>
+                <a:ea typeface="Calibri" pitchFamily="34" charset="-122"/>
+                <a:cs typeface="Calibri" pitchFamily="34" charset="-120"/>
+              </a:rPr>
+              <a:t>OS4LS 2026  ·  ITK-SNAP AI-Native, Human-in-the-Loop Segmentation</a:t>
+            </a:r>
+            <a:endParaRPr lang="en-US" sz="900" dirty="0"/>
+          </a:p>
+        </p:txBody>
+      </p:sp>
+      <p:sp>
+        <p:nvSpPr>
+          <p:cNvPr id="33" name="Text 25"/>
+          <p:cNvSpPr/>
+          <p:nvPr/>
+        </p:nvSpPr>
+        <p:spPr>
+          <a:xfrm>
+            <a:off x="11274552" y="6446520"/>
+            <a:ext cx="365760" cy="274320"/>
+          </a:xfrm>
+          <a:prstGeom prst="rect">
+            <a:avLst/>
+          </a:prstGeom>
+          <a:noFill/>
+          <a:ln/>
+        </p:spPr>
+        <p:txBody>
+          <a:bodyPr wrap="square" lIns="0" tIns="0" rIns="0" bIns="0" rtlCol="0" anchor="ctr"/>
+          <a:lstStyle/>
+          <a:p>
+            <a:pPr algn="r" indent="0" marL="0">
+              <a:buNone/>
+            </a:pPr>
+            <a:r>
+              <a:rPr lang="en-US" sz="900" dirty="0">
+                <a:solidFill>
+                  <a:srgbClr val="6B7B8C"/>
+                </a:solidFill>
+                <a:latin typeface="Calibri" pitchFamily="34" charset="0"/>
+                <a:ea typeface="Calibri" pitchFamily="34" charset="-122"/>
+                <a:cs typeface="Calibri" pitchFamily="34" charset="-120"/>
+              </a:rPr>
+              <a:t>12</a:t>
+            </a:r>
+            <a:endParaRPr lang="en-US" sz="900" dirty="0"/>
+          </a:p>
+        </p:txBody>
+      </p:sp>
+    </p:spTree>
+  </p:cSld>
+  <p:clrMapOvr>
+    <a:masterClrMapping/>
+  </p:clrMapOvr>
+</p:sld>
+</file>
+
+<file path=ppt/slides/slide13.xml><?xml version="1.0" encoding="utf-8"?>
+<p:sld xmlns:a="http://schemas.openxmlformats.org/drawingml/2006/main" xmlns:r="http://schemas.openxmlformats.org/officeDocument/2006/relationships" xmlns:p="http://schemas.openxmlformats.org/presentationml/2006/main">
+  <p:cSld name="Slide 13">
+    <p:bg>
+      <p:bgPr>
+        <a:solidFill>
+          <a:srgbClr val="F4F7FB"/>
+        </a:solidFill>
+      </p:bgPr>
+    </p:bg>
+    <p:spTree>
+      <p:nvGrpSpPr>
+        <p:cNvPr id="1" name=""/>
+        <p:cNvGrpSpPr/>
+        <p:nvPr/>
+      </p:nvGrpSpPr>
+      <p:grpSpPr>
+        <a:xfrm>
+          <a:off x="0" y="0"/>
+          <a:ext cx="0" cy="0"/>
+          <a:chOff x="0" y="0"/>
+          <a:chExt cx="0" cy="0"/>
+        </a:xfrm>
+      </p:grpSpPr>
+      <p:sp>
+        <p:nvSpPr>
+          <p:cNvPr id="2" name="Shape 0"/>
+          <p:cNvSpPr/>
+          <p:nvPr/>
+        </p:nvSpPr>
+        <p:spPr>
+          <a:xfrm>
+            <a:off x="548640" y="420624"/>
+            <a:ext cx="146304" cy="457200"/>
+          </a:xfrm>
+          <a:prstGeom prst="rect">
+            <a:avLst/>
+          </a:prstGeom>
+          <a:solidFill>
+            <a:srgbClr val="1496A6"/>
+          </a:solidFill>
+          <a:ln/>
+        </p:spPr>
+      </p:sp>
+      <p:sp>
+        <p:nvSpPr>
+          <p:cNvPr id="3" name="Text 1"/>
+          <p:cNvSpPr/>
+          <p:nvPr/>
+        </p:nvSpPr>
+        <p:spPr>
+          <a:xfrm>
+            <a:off x="804672" y="402336"/>
+            <a:ext cx="10515600" cy="274320"/>
+          </a:xfrm>
+          <a:prstGeom prst="rect">
+            <a:avLst/>
+          </a:prstGeom>
+          <a:noFill/>
+          <a:ln/>
+        </p:spPr>
+        <p:txBody>
+          <a:bodyPr wrap="square" lIns="0" tIns="0" rIns="0" bIns="0" rtlCol="0" anchor="ctr"/>
+          <a:lstStyle/>
+          <a:p>
+            <a:pPr indent="0" marL="0">
+              <a:buNone/>
+            </a:pPr>
+            <a:r>
+              <a:rPr lang="en-US" sz="1300" b="1" spc="200" kern="0" dirty="0">
+                <a:solidFill>
+                  <a:srgbClr val="13678A"/>
+                </a:solidFill>
+                <a:latin typeface="Trebuchet MS" pitchFamily="34" charset="0"/>
+                <a:ea typeface="Trebuchet MS" pitchFamily="34" charset="-122"/>
+                <a:cs typeface="Trebuchet MS" pitchFamily="34" charset="-120"/>
+              </a:rPr>
+              <a:t>DELIVERY CAPACITY</a:t>
+            </a:r>
+            <a:endParaRPr lang="en-US" sz="1300" dirty="0"/>
+          </a:p>
+        </p:txBody>
+      </p:sp>
+      <p:sp>
+        <p:nvSpPr>
+          <p:cNvPr id="4" name="Text 2"/>
+          <p:cNvSpPr/>
+          <p:nvPr/>
+        </p:nvSpPr>
+        <p:spPr>
+          <a:xfrm>
+            <a:off x="804672" y="658368"/>
+            <a:ext cx="11155680" cy="566928"/>
+          </a:xfrm>
+          <a:prstGeom prst="rect">
+            <a:avLst/>
+          </a:prstGeom>
+          <a:noFill/>
+          <a:ln/>
+        </p:spPr>
+        <p:txBody>
+          <a:bodyPr wrap="square" lIns="0" tIns="0" rIns="0" bIns="0" rtlCol="0" anchor="ctr"/>
+          <a:lstStyle/>
+          <a:p>
+            <a:pPr indent="0" marL="0">
+              <a:buNone/>
+            </a:pPr>
+            <a:r>
+              <a:rPr lang="en-US" sz="2700" b="1" dirty="0">
+                <a:solidFill>
+                  <a:srgbClr val="0B2545"/>
+                </a:solidFill>
+                <a:latin typeface="Trebuchet MS" pitchFamily="34" charset="0"/>
+                <a:ea typeface="Trebuchet MS" pitchFamily="34" charset="-122"/>
+                <a:cs typeface="Trebuchet MS" pitchFamily="34" charset="-120"/>
+              </a:rPr>
+              <a:t>Why we can build it in two years</a:t>
+            </a:r>
+            <a:endParaRPr lang="en-US" sz="2700" dirty="0"/>
+          </a:p>
+        </p:txBody>
+      </p:sp>
+      <p:sp>
+        <p:nvSpPr>
+          <p:cNvPr id="5" name="Shape 3"/>
+          <p:cNvSpPr/>
+          <p:nvPr/>
+        </p:nvSpPr>
+        <p:spPr>
+          <a:xfrm>
+            <a:off x="548640" y="1691640"/>
+            <a:ext cx="5362956" cy="1783080"/>
+          </a:xfrm>
+          <a:prstGeom prst="roundRect">
+            <a:avLst>
+              <a:gd name="adj" fmla="val 4103"/>
+            </a:avLst>
+          </a:prstGeom>
+          <a:solidFill>
+            <a:srgbClr val="FFFFFF"/>
+          </a:solidFill>
+          <a:ln w="12700">
+            <a:solidFill>
+              <a:srgbClr val="DCE5EF"/>
+            </a:solidFill>
+            <a:prstDash val="solid"/>
+          </a:ln>
+          <a:effectLst>
+            <a:outerShdw sx="100000" sy="100000" kx="0" ky="0" algn="bl" rotWithShape="0" blurRad="114300" dist="38100" dir="5400000">
+              <a:srgbClr val="0B2545">
+                <a:alpha val="16000"/>
+              </a:srgbClr>
+            </a:outerShdw>
+          </a:effectLst>
+        </p:spPr>
+      </p:sp>
+      <p:sp>
+        <p:nvSpPr>
+          <p:cNvPr id="6" name="Shape 4"/>
+          <p:cNvSpPr/>
+          <p:nvPr/>
+        </p:nvSpPr>
+        <p:spPr>
+          <a:xfrm>
+            <a:off x="841248" y="2039112"/>
+            <a:ext cx="713232" cy="713232"/>
+          </a:xfrm>
+          <a:prstGeom prst="ellipse">
+            <a:avLst/>
+          </a:prstGeom>
+          <a:solidFill>
+            <a:srgbClr val="1496A6"/>
+          </a:solidFill>
+          <a:ln/>
+        </p:spPr>
+      </p:sp>
+      <p:pic>
+        <p:nvPicPr>
+          <p:cNvPr id="7" name="Image 0" descr="preencoded.png">    </p:cNvPr>
+          <p:cNvPicPr>
+            <a:picLocks noChangeAspect="1"/>
+          </p:cNvPicPr>
+          <p:nvPr/>
+        </p:nvPicPr>
+        <p:blipFill>
+          <a:blip r:embed="rId1"/>
+          <a:stretch>
+            <a:fillRect/>
+          </a:stretch>
+        </p:blipFill>
+        <p:spPr>
+          <a:xfrm>
+            <a:off x="1042416" y="2240280"/>
+            <a:ext cx="310896" cy="310896"/>
+          </a:xfrm>
+          <a:prstGeom prst="rect">
+            <a:avLst/>
+          </a:prstGeom>
+        </p:spPr>
+      </p:pic>
+      <p:sp>
+        <p:nvSpPr>
+          <p:cNvPr id="8" name="Text 5"/>
+          <p:cNvSpPr/>
+          <p:nvPr/>
+        </p:nvSpPr>
+        <p:spPr>
+          <a:xfrm>
+            <a:off x="1783080" y="1984248"/>
+            <a:ext cx="3899916" cy="411480"/>
+          </a:xfrm>
+          <a:prstGeom prst="rect">
+            <a:avLst/>
+          </a:prstGeom>
+          <a:noFill/>
+          <a:ln/>
+        </p:spPr>
+        <p:txBody>
+          <a:bodyPr wrap="square" lIns="0" tIns="0" rIns="0" bIns="0" rtlCol="0" anchor="ctr"/>
+          <a:lstStyle/>
+          <a:p>
+            <a:pPr indent="0" marL="0">
+              <a:buNone/>
+            </a:pPr>
+            <a:r>
+              <a:rPr lang="en-US" sz="1700" b="1" dirty="0">
+                <a:solidFill>
+                  <a:srgbClr val="0B2545"/>
+                </a:solidFill>
+                <a:latin typeface="Trebuchet MS" pitchFamily="34" charset="0"/>
+                <a:ea typeface="Trebuchet MS" pitchFamily="34" charset="-122"/>
+                <a:cs typeface="Trebuchet MS" pitchFamily="34" charset="-120"/>
+              </a:rPr>
+              <a:t>Coding-agent multiplier</a:t>
+            </a:r>
+            <a:endParaRPr lang="en-US" sz="1700" dirty="0"/>
+          </a:p>
+        </p:txBody>
+      </p:sp>
+      <p:sp>
+        <p:nvSpPr>
+          <p:cNvPr id="9" name="Text 6"/>
+          <p:cNvSpPr/>
+          <p:nvPr/>
+        </p:nvSpPr>
+        <p:spPr>
+          <a:xfrm>
+            <a:off x="1783080" y="2404872"/>
+            <a:ext cx="3899916" cy="960120"/>
+          </a:xfrm>
+          <a:prstGeom prst="rect">
+            <a:avLst/>
+          </a:prstGeom>
+          <a:noFill/>
+          <a:ln/>
+        </p:spPr>
+        <p:txBody>
+          <a:bodyPr wrap="square" lIns="0" tIns="0" rIns="0" bIns="0" rtlCol="0" anchor="t"/>
+          <a:lstStyle/>
+          <a:p>
+            <a:pPr indent="0" marL="0">
+              <a:buNone/>
+            </a:pPr>
+            <a:r>
+              <a:rPr lang="en-US" sz="1250" dirty="0">
+                <a:solidFill>
+                  <a:srgbClr val="33495C"/>
+                </a:solidFill>
+                <a:latin typeface="Calibri" pitchFamily="34" charset="0"/>
+                <a:ea typeface="Calibri" pitchFamily="34" charset="-122"/>
+                <a:cs typeface="Calibri" pitchFamily="34" charset="-120"/>
+              </a:rPr>
+              <a:t>Modern AI coding agents turn a ~3–4 FTE-year scope into something a focused team can deliver — and it dogfoods the very thing we're building.</a:t>
+            </a:r>
+            <a:endParaRPr lang="en-US" sz="1250" dirty="0"/>
+          </a:p>
+        </p:txBody>
+      </p:sp>
+      <p:sp>
+        <p:nvSpPr>
+          <p:cNvPr id="10" name="Shape 7"/>
+          <p:cNvSpPr/>
+          <p:nvPr/>
+        </p:nvSpPr>
+        <p:spPr>
+          <a:xfrm>
+            <a:off x="6277356" y="1691640"/>
+            <a:ext cx="5362956" cy="1783080"/>
+          </a:xfrm>
+          <a:prstGeom prst="roundRect">
+            <a:avLst>
+              <a:gd name="adj" fmla="val 4103"/>
+            </a:avLst>
+          </a:prstGeom>
+          <a:solidFill>
+            <a:srgbClr val="FFFFFF"/>
+          </a:solidFill>
+          <a:ln w="12700">
+            <a:solidFill>
+              <a:srgbClr val="DCE5EF"/>
+            </a:solidFill>
+            <a:prstDash val="solid"/>
+          </a:ln>
+          <a:effectLst>
+            <a:outerShdw sx="100000" sy="100000" kx="0" ky="0" algn="bl" rotWithShape="0" blurRad="114300" dist="38100" dir="5400000">
+              <a:srgbClr val="0B2545">
+                <a:alpha val="16000"/>
+              </a:srgbClr>
+            </a:outerShdw>
+          </a:effectLst>
+        </p:spPr>
+      </p:sp>
+      <p:sp>
+        <p:nvSpPr>
+          <p:cNvPr id="11" name="Shape 8"/>
+          <p:cNvSpPr/>
+          <p:nvPr/>
+        </p:nvSpPr>
+        <p:spPr>
+          <a:xfrm>
+            <a:off x="6569964" y="2039112"/>
+            <a:ext cx="713232" cy="713232"/>
+          </a:xfrm>
+          <a:prstGeom prst="ellipse">
+            <a:avLst/>
+          </a:prstGeom>
+          <a:solidFill>
+            <a:srgbClr val="E8924A"/>
+          </a:solidFill>
+          <a:ln/>
+        </p:spPr>
+      </p:sp>
+      <p:pic>
+        <p:nvPicPr>
+          <p:cNvPr id="12" name="Image 1" descr="preencoded.png">    </p:cNvPr>
+          <p:cNvPicPr>
+            <a:picLocks noChangeAspect="1"/>
+          </p:cNvPicPr>
+          <p:nvPr/>
+        </p:nvPicPr>
+        <p:blipFill>
+          <a:blip r:embed="rId2"/>
+          <a:stretch>
+            <a:fillRect/>
+          </a:stretch>
+        </p:blipFill>
+        <p:spPr>
+          <a:xfrm>
+            <a:off x="6771132" y="2240280"/>
+            <a:ext cx="310896" cy="310896"/>
+          </a:xfrm>
+          <a:prstGeom prst="rect">
+            <a:avLst/>
+          </a:prstGeom>
+        </p:spPr>
+      </p:pic>
+      <p:sp>
+        <p:nvSpPr>
+          <p:cNvPr id="13" name="Text 9"/>
+          <p:cNvSpPr/>
+          <p:nvPr/>
+        </p:nvSpPr>
+        <p:spPr>
+          <a:xfrm>
+            <a:off x="7511796" y="1984248"/>
+            <a:ext cx="3899916" cy="411480"/>
+          </a:xfrm>
+          <a:prstGeom prst="rect">
+            <a:avLst/>
+          </a:prstGeom>
+          <a:noFill/>
+          <a:ln/>
+        </p:spPr>
+        <p:txBody>
+          <a:bodyPr wrap="square" lIns="0" tIns="0" rIns="0" bIns="0" rtlCol="0" anchor="ctr"/>
+          <a:lstStyle/>
+          <a:p>
+            <a:pPr indent="0" marL="0">
+              <a:buNone/>
+            </a:pPr>
+            <a:r>
+              <a:rPr lang="en-US" sz="1700" b="1" dirty="0">
+                <a:solidFill>
+                  <a:srgbClr val="0B2545"/>
+                </a:solidFill>
+                <a:latin typeface="Trebuchet MS" pitchFamily="34" charset="0"/>
+                <a:ea typeface="Trebuchet MS" pitchFamily="34" charset="-122"/>
+                <a:cs typeface="Trebuchet MS" pitchFamily="34" charset="-120"/>
+              </a:rPr>
+              <a:t>Integration, not invention</a:t>
+            </a:r>
+            <a:endParaRPr lang="en-US" sz="1700" dirty="0"/>
+          </a:p>
+        </p:txBody>
+      </p:sp>
+      <p:sp>
+        <p:nvSpPr>
+          <p:cNvPr id="14" name="Text 10"/>
+          <p:cNvSpPr/>
+          <p:nvPr/>
+        </p:nvSpPr>
+        <p:spPr>
+          <a:xfrm>
+            <a:off x="7511796" y="2404872"/>
+            <a:ext cx="3899916" cy="960120"/>
+          </a:xfrm>
+          <a:prstGeom prst="rect">
+            <a:avLst/>
+          </a:prstGeom>
+          <a:noFill/>
+          <a:ln/>
+        </p:spPr>
+        <p:txBody>
+          <a:bodyPr wrap="square" lIns="0" tIns="0" rIns="0" bIns="0" rtlCol="0" anchor="t"/>
+          <a:lstStyle/>
+          <a:p>
+            <a:pPr indent="0" marL="0">
+              <a:buNone/>
+            </a:pPr>
+            <a:r>
+              <a:rPr lang="en-US" sz="1250" dirty="0">
+                <a:solidFill>
+                  <a:srgbClr val="33495C"/>
+                </a:solidFill>
+                <a:latin typeface="Calibri" pitchFamily="34" charset="0"/>
+                <a:ea typeface="Calibri" pitchFamily="34" charset="-122"/>
+                <a:cs typeface="Calibri" pitchFamily="34" charset="-120"/>
+              </a:rPr>
+              <a:t>Most work wires together mature components: itksnap-dls, greedy, SegFlow4D, FireANTs, WorkspaceAPI, MONAI, Hugging Face.</a:t>
+            </a:r>
+            <a:endParaRPr lang="en-US" sz="1250" dirty="0"/>
+          </a:p>
+        </p:txBody>
+      </p:sp>
+      <p:sp>
+        <p:nvSpPr>
+          <p:cNvPr id="15" name="Shape 11"/>
+          <p:cNvSpPr/>
+          <p:nvPr/>
+        </p:nvSpPr>
+        <p:spPr>
+          <a:xfrm>
+            <a:off x="548640" y="3657600"/>
+            <a:ext cx="5362956" cy="1783080"/>
+          </a:xfrm>
+          <a:prstGeom prst="roundRect">
+            <a:avLst>
+              <a:gd name="adj" fmla="val 4103"/>
+            </a:avLst>
+          </a:prstGeom>
+          <a:solidFill>
+            <a:srgbClr val="FFFFFF"/>
+          </a:solidFill>
+          <a:ln w="12700">
+            <a:solidFill>
+              <a:srgbClr val="DCE5EF"/>
+            </a:solidFill>
+            <a:prstDash val="solid"/>
+          </a:ln>
+          <a:effectLst>
+            <a:outerShdw sx="100000" sy="100000" kx="0" ky="0" algn="bl" rotWithShape="0" blurRad="114300" dist="38100" dir="5400000">
+              <a:srgbClr val="0B2545">
+                <a:alpha val="16000"/>
+              </a:srgbClr>
+            </a:outerShdw>
+          </a:effectLst>
+        </p:spPr>
+      </p:sp>
+      <p:sp>
+        <p:nvSpPr>
+          <p:cNvPr id="16" name="Shape 12"/>
+          <p:cNvSpPr/>
+          <p:nvPr/>
+        </p:nvSpPr>
+        <p:spPr>
+          <a:xfrm>
+            <a:off x="841248" y="4005072"/>
+            <a:ext cx="713232" cy="713232"/>
+          </a:xfrm>
+          <a:prstGeom prst="ellipse">
+            <a:avLst/>
+          </a:prstGeom>
+          <a:solidFill>
+            <a:srgbClr val="13678A"/>
+          </a:solidFill>
+          <a:ln/>
+        </p:spPr>
+      </p:sp>
+      <p:pic>
+        <p:nvPicPr>
+          <p:cNvPr id="17" name="Image 2" descr="preencoded.png">    </p:cNvPr>
+          <p:cNvPicPr>
+            <a:picLocks noChangeAspect="1"/>
+          </p:cNvPicPr>
+          <p:nvPr/>
+        </p:nvPicPr>
+        <p:blipFill>
+          <a:blip r:embed="rId3"/>
+          <a:stretch>
+            <a:fillRect/>
+          </a:stretch>
+        </p:blipFill>
+        <p:spPr>
+          <a:xfrm>
+            <a:off x="1042416" y="4206240"/>
+            <a:ext cx="310896" cy="310896"/>
+          </a:xfrm>
+          <a:prstGeom prst="rect">
+            <a:avLst/>
+          </a:prstGeom>
+        </p:spPr>
+      </p:pic>
+      <p:sp>
+        <p:nvSpPr>
+          <p:cNvPr id="18" name="Text 13"/>
+          <p:cNvSpPr/>
+          <p:nvPr/>
+        </p:nvSpPr>
+        <p:spPr>
+          <a:xfrm>
+            <a:off x="1783080" y="3950208"/>
+            <a:ext cx="3899916" cy="411480"/>
+          </a:xfrm>
+          <a:prstGeom prst="rect">
+            <a:avLst/>
+          </a:prstGeom>
+          <a:noFill/>
+          <a:ln/>
+        </p:spPr>
+        <p:txBody>
+          <a:bodyPr wrap="square" lIns="0" tIns="0" rIns="0" bIns="0" rtlCol="0" anchor="ctr"/>
+          <a:lstStyle/>
+          <a:p>
+            <a:pPr indent="0" marL="0">
+              <a:buNone/>
+            </a:pPr>
+            <a:r>
+              <a:rPr lang="en-US" sz="1700" b="1" dirty="0">
+                <a:solidFill>
+                  <a:srgbClr val="0B2545"/>
+                </a:solidFill>
+                <a:latin typeface="Trebuchet MS" pitchFamily="34" charset="0"/>
+                <a:ea typeface="Trebuchet MS" pitchFamily="34" charset="-122"/>
+                <a:cs typeface="Trebuchet MS" pitchFamily="34" charset="-120"/>
+              </a:rPr>
+              <a:t>Clean architecture</a:t>
+            </a:r>
+            <a:endParaRPr lang="en-US" sz="1700" dirty="0"/>
+          </a:p>
+        </p:txBody>
+      </p:sp>
+      <p:sp>
+        <p:nvSpPr>
+          <p:cNvPr id="19" name="Text 14"/>
+          <p:cNvSpPr/>
+          <p:nvPr/>
+        </p:nvSpPr>
+        <p:spPr>
+          <a:xfrm>
+            <a:off x="1783080" y="4370832"/>
+            <a:ext cx="3899916" cy="960120"/>
+          </a:xfrm>
+          <a:prstGeom prst="rect">
+            <a:avLst/>
+          </a:prstGeom>
+          <a:noFill/>
+          <a:ln/>
+        </p:spPr>
+        <p:txBody>
+          <a:bodyPr wrap="square" lIns="0" tIns="0" rIns="0" bIns="0" rtlCol="0" anchor="t"/>
+          <a:lstStyle/>
+          <a:p>
+            <a:pPr indent="0" marL="0">
+              <a:buNone/>
+            </a:pPr>
+            <a:r>
+              <a:rPr lang="en-US" sz="1250" dirty="0">
+                <a:solidFill>
+                  <a:srgbClr val="33495C"/>
+                </a:solidFill>
+                <a:latin typeface="Calibri" pitchFamily="34" charset="0"/>
+                <a:ea typeface="Calibri" pitchFamily="34" charset="-122"/>
+                <a:cs typeface="Calibri" pitchFamily="34" charset="-120"/>
+              </a:rPr>
+              <a:t>ITK-SNAP's strict three-layer separation gives agents clear contracts to target — fast, low-error work.</a:t>
+            </a:r>
+            <a:endParaRPr lang="en-US" sz="1250" dirty="0"/>
+          </a:p>
+        </p:txBody>
+      </p:sp>
+      <p:sp>
+        <p:nvSpPr>
+          <p:cNvPr id="20" name="Shape 15"/>
+          <p:cNvSpPr/>
+          <p:nvPr/>
+        </p:nvSpPr>
+        <p:spPr>
+          <a:xfrm>
+            <a:off x="6277356" y="3657600"/>
+            <a:ext cx="5362956" cy="1783080"/>
+          </a:xfrm>
+          <a:prstGeom prst="roundRect">
+            <a:avLst>
+              <a:gd name="adj" fmla="val 4103"/>
+            </a:avLst>
+          </a:prstGeom>
+          <a:solidFill>
+            <a:srgbClr val="FFFFFF"/>
+          </a:solidFill>
+          <a:ln w="12700">
+            <a:solidFill>
+              <a:srgbClr val="DCE5EF"/>
+            </a:solidFill>
+            <a:prstDash val="solid"/>
+          </a:ln>
+          <a:effectLst>
+            <a:outerShdw sx="100000" sy="100000" kx="0" ky="0" algn="bl" rotWithShape="0" blurRad="114300" dist="38100" dir="5400000">
+              <a:srgbClr val="0B2545">
+                <a:alpha val="16000"/>
+              </a:srgbClr>
+            </a:outerShdw>
+          </a:effectLst>
+        </p:spPr>
+      </p:sp>
+      <p:sp>
+        <p:nvSpPr>
+          <p:cNvPr id="21" name="Shape 16"/>
+          <p:cNvSpPr/>
+          <p:nvPr/>
+        </p:nvSpPr>
+        <p:spPr>
+          <a:xfrm>
+            <a:off x="6569964" y="4005072"/>
+            <a:ext cx="713232" cy="713232"/>
+          </a:xfrm>
+          <a:prstGeom prst="ellipse">
+            <a:avLst/>
+          </a:prstGeom>
+          <a:solidFill>
+            <a:srgbClr val="2BB3A3"/>
+          </a:solidFill>
+          <a:ln/>
+        </p:spPr>
+      </p:sp>
+      <p:pic>
+        <p:nvPicPr>
+          <p:cNvPr id="22" name="Image 3" descr="preencoded.png">    </p:cNvPr>
+          <p:cNvPicPr>
+            <a:picLocks noChangeAspect="1"/>
+          </p:cNvPicPr>
+          <p:nvPr/>
+        </p:nvPicPr>
+        <p:blipFill>
+          <a:blip r:embed="rId4"/>
+          <a:stretch>
+            <a:fillRect/>
+          </a:stretch>
+        </p:blipFill>
+        <p:spPr>
+          <a:xfrm>
+            <a:off x="6771132" y="4206240"/>
+            <a:ext cx="310896" cy="310896"/>
+          </a:xfrm>
+          <a:prstGeom prst="rect">
+            <a:avLst/>
+          </a:prstGeom>
+        </p:spPr>
+      </p:pic>
+      <p:sp>
+        <p:nvSpPr>
+          <p:cNvPr id="23" name="Text 17"/>
+          <p:cNvSpPr/>
+          <p:nvPr/>
+        </p:nvSpPr>
+        <p:spPr>
+          <a:xfrm>
+            <a:off x="7511796" y="3950208"/>
+            <a:ext cx="3899916" cy="411480"/>
+          </a:xfrm>
+          <a:prstGeom prst="rect">
+            <a:avLst/>
+          </a:prstGeom>
+          <a:noFill/>
+          <a:ln/>
+        </p:spPr>
+        <p:txBody>
+          <a:bodyPr wrap="square" lIns="0" tIns="0" rIns="0" bIns="0" rtlCol="0" anchor="ctr"/>
+          <a:lstStyle/>
+          <a:p>
+            <a:pPr indent="0" marL="0">
+              <a:buNone/>
+            </a:pPr>
+            <a:r>
+              <a:rPr lang="en-US" sz="1700" b="1" dirty="0">
+                <a:solidFill>
+                  <a:srgbClr val="0B2545"/>
+                </a:solidFill>
+                <a:latin typeface="Trebuchet MS" pitchFamily="34" charset="0"/>
+                <a:ea typeface="Trebuchet MS" pitchFamily="34" charset="-122"/>
+                <a:cs typeface="Trebuchet MS" pitchFamily="34" charset="-120"/>
+              </a:rPr>
+              <a:t>Automated safety net</a:t>
+            </a:r>
+            <a:endParaRPr lang="en-US" sz="1700" dirty="0"/>
+          </a:p>
+        </p:txBody>
+      </p:sp>
+      <p:sp>
+        <p:nvSpPr>
+          <p:cNvPr id="24" name="Text 18"/>
+          <p:cNvSpPr/>
+          <p:nvPr/>
+        </p:nvSpPr>
+        <p:spPr>
+          <a:xfrm>
+            <a:off x="7511796" y="4370832"/>
+            <a:ext cx="3899916" cy="960120"/>
+          </a:xfrm>
+          <a:prstGeom prst="rect">
+            <a:avLst/>
+          </a:prstGeom>
+          <a:noFill/>
+          <a:ln/>
+        </p:spPr>
+        <p:txBody>
+          <a:bodyPr wrap="square" lIns="0" tIns="0" rIns="0" bIns="0" rtlCol="0" anchor="t"/>
+          <a:lstStyle/>
+          <a:p>
+            <a:pPr indent="0" marL="0">
+              <a:buNone/>
+            </a:pPr>
+            <a:r>
+              <a:rPr lang="en-US" sz="1250" dirty="0">
+                <a:solidFill>
+                  <a:srgbClr val="33495C"/>
+                </a:solidFill>
+                <a:latin typeface="Calibri" pitchFamily="34" charset="0"/>
+                <a:ea typeface="Calibri" pitchFamily="34" charset="-122"/>
+                <a:cs typeface="Calibri" pitchFamily="34" charset="-120"/>
+              </a:rPr>
+              <a:t>The scripted --test harness + CI conformance gate agent-generated code by tests, not trust.</a:t>
+            </a:r>
+            <a:endParaRPr lang="en-US" sz="1250" dirty="0"/>
+          </a:p>
+        </p:txBody>
+      </p:sp>
+      <p:sp>
+        <p:nvSpPr>
+          <p:cNvPr id="25" name="Shape 19"/>
+          <p:cNvSpPr/>
+          <p:nvPr/>
+        </p:nvSpPr>
+        <p:spPr>
+          <a:xfrm>
+            <a:off x="548640" y="5715000"/>
+            <a:ext cx="11091672" cy="566928"/>
+          </a:xfrm>
+          <a:prstGeom prst="roundRect">
+            <a:avLst>
+              <a:gd name="adj" fmla="val 9677"/>
+            </a:avLst>
+          </a:prstGeom>
+          <a:solidFill>
+            <a:srgbClr val="E8F1F4"/>
+          </a:solidFill>
+          <a:ln w="12700">
+            <a:solidFill>
+              <a:srgbClr val="C9DEE4"/>
+            </a:solidFill>
+            <a:prstDash val="solid"/>
+          </a:ln>
+        </p:spPr>
+      </p:sp>
+      <p:pic>
+        <p:nvPicPr>
+          <p:cNvPr id="26" name="Image 4" descr="preencoded.png">    </p:cNvPr>
+          <p:cNvPicPr>
+            <a:picLocks noChangeAspect="1"/>
+          </p:cNvPicPr>
+          <p:nvPr/>
+        </p:nvPicPr>
+        <p:blipFill>
+          <a:blip r:embed="rId5"/>
+          <a:stretch>
+            <a:fillRect/>
+          </a:stretch>
+        </p:blipFill>
+        <p:spPr>
+          <a:xfrm>
+            <a:off x="749808" y="5870448"/>
+            <a:ext cx="256032" cy="256032"/>
+          </a:xfrm>
+          <a:prstGeom prst="rect">
+            <a:avLst/>
+          </a:prstGeom>
+        </p:spPr>
+      </p:pic>
+      <p:sp>
+        <p:nvSpPr>
+          <p:cNvPr id="27" name="Text 20"/>
+          <p:cNvSpPr/>
+          <p:nvPr/>
+        </p:nvSpPr>
+        <p:spPr>
+          <a:xfrm>
+            <a:off x="1115568" y="5715000"/>
+            <a:ext cx="10360152" cy="566928"/>
+          </a:xfrm>
+          <a:prstGeom prst="rect">
+            <a:avLst/>
+          </a:prstGeom>
+          <a:noFill/>
+          <a:ln/>
+        </p:spPr>
+        <p:txBody>
+          <a:bodyPr wrap="square" lIns="0" tIns="0" rIns="0" bIns="0" rtlCol="0" anchor="ctr"/>
+          <a:lstStyle/>
+          <a:p>
+            <a:pPr indent="0" marL="0">
+              <a:buNone/>
+            </a:pPr>
+            <a:r>
+              <a:rPr lang="en-US" sz="1250" b="1" dirty="0">
+                <a:solidFill>
+                  <a:srgbClr val="13678A"/>
+                </a:solidFill>
+                <a:latin typeface="Calibri" pitchFamily="34" charset="0"/>
+                <a:ea typeface="Calibri" pitchFamily="34" charset="-122"/>
+                <a:cs typeface="Calibri" pitchFamily="34" charset="-120"/>
+              </a:rPr>
+              <a:t>Anchored on shipped, adopted code — a mature project, not a prototype or a rewrite.</a:t>
+            </a:r>
+            <a:endParaRPr lang="en-US" sz="1250" dirty="0"/>
+          </a:p>
+        </p:txBody>
+      </p:sp>
+      <p:sp>
+        <p:nvSpPr>
+          <p:cNvPr id="28" name="Text 21"/>
+          <p:cNvSpPr/>
+          <p:nvPr/>
+        </p:nvSpPr>
+        <p:spPr>
+          <a:xfrm>
+            <a:off x="548640" y="6446520"/>
+            <a:ext cx="8229600" cy="274320"/>
+          </a:xfrm>
+          <a:prstGeom prst="rect">
+            <a:avLst/>
+          </a:prstGeom>
+          <a:noFill/>
+          <a:ln/>
+        </p:spPr>
+        <p:txBody>
+          <a:bodyPr wrap="square" lIns="0" tIns="0" rIns="0" bIns="0" rtlCol="0" anchor="ctr"/>
+          <a:lstStyle/>
+          <a:p>
+            <a:pPr indent="0" marL="0">
+              <a:buNone/>
+            </a:pPr>
+            <a:r>
+              <a:rPr lang="en-US" sz="900" dirty="0">
+                <a:solidFill>
+                  <a:srgbClr val="6B7B8C"/>
+                </a:solidFill>
+                <a:latin typeface="Calibri" pitchFamily="34" charset="0"/>
+                <a:ea typeface="Calibri" pitchFamily="34" charset="-122"/>
+                <a:cs typeface="Calibri" pitchFamily="34" charset="-120"/>
+              </a:rPr>
+              <a:t>OS4LS 2026  ·  ITK-SNAP AI-Native, Human-in-the-Loop Segmentation</a:t>
+            </a:r>
+            <a:endParaRPr lang="en-US" sz="900" dirty="0"/>
+          </a:p>
+        </p:txBody>
+      </p:sp>
+      <p:sp>
+        <p:nvSpPr>
+          <p:cNvPr id="29" name="Text 22"/>
+          <p:cNvSpPr/>
+          <p:nvPr/>
+        </p:nvSpPr>
+        <p:spPr>
+          <a:xfrm>
+            <a:off x="11274552" y="6446520"/>
+            <a:ext cx="365760" cy="274320"/>
+          </a:xfrm>
+          <a:prstGeom prst="rect">
+            <a:avLst/>
+          </a:prstGeom>
+          <a:noFill/>
+          <a:ln/>
+        </p:spPr>
+        <p:txBody>
+          <a:bodyPr wrap="square" lIns="0" tIns="0" rIns="0" bIns="0" rtlCol="0" anchor="ctr"/>
+          <a:lstStyle/>
+          <a:p>
+            <a:pPr algn="r" indent="0" marL="0">
+              <a:buNone/>
+            </a:pPr>
+            <a:r>
+              <a:rPr lang="en-US" sz="900" dirty="0">
+                <a:solidFill>
+                  <a:srgbClr val="6B7B8C"/>
+                </a:solidFill>
+                <a:latin typeface="Calibri" pitchFamily="34" charset="0"/>
+                <a:ea typeface="Calibri" pitchFamily="34" charset="-122"/>
+                <a:cs typeface="Calibri" pitchFamily="34" charset="-120"/>
+              </a:rPr>
+              <a:t>13</a:t>
+            </a:r>
+            <a:endParaRPr lang="en-US" sz="900" dirty="0"/>
+          </a:p>
+        </p:txBody>
+      </p:sp>
+    </p:spTree>
+  </p:cSld>
+  <p:clrMapOvr>
+    <a:masterClrMapping/>
+  </p:clrMapOvr>
+</p:sld>
+</file>
+
+<file path=ppt/slides/slide14.xml><?xml version="1.0" encoding="utf-8"?>
+<p:sld xmlns:a="http://schemas.openxmlformats.org/drawingml/2006/main" xmlns:r="http://schemas.openxmlformats.org/officeDocument/2006/relationships" xmlns:p="http://schemas.openxmlformats.org/presentationml/2006/main">
+  <p:cSld name="Slide 14">
+    <p:bg>
+      <p:bgPr>
+        <a:solidFill>
+          <a:srgbClr val="F4F7FB"/>
+        </a:solidFill>
+      </p:bgPr>
+    </p:bg>
+    <p:spTree>
+      <p:nvGrpSpPr>
+        <p:cNvPr id="1" name=""/>
+        <p:cNvGrpSpPr/>
+        <p:nvPr/>
+      </p:nvGrpSpPr>
+      <p:grpSpPr>
+        <a:xfrm>
+          <a:off x="0" y="0"/>
+          <a:ext cx="0" cy="0"/>
+          <a:chOff x="0" y="0"/>
+          <a:chExt cx="0" cy="0"/>
+        </a:xfrm>
+      </p:grpSpPr>
+      <p:sp>
+        <p:nvSpPr>
+          <p:cNvPr id="2" name="Shape 0"/>
+          <p:cNvSpPr/>
+          <p:nvPr/>
+        </p:nvSpPr>
+        <p:spPr>
+          <a:xfrm>
+            <a:off x="548640" y="420624"/>
+            <a:ext cx="146304" cy="457200"/>
+          </a:xfrm>
+          <a:prstGeom prst="rect">
+            <a:avLst/>
+          </a:prstGeom>
+          <a:solidFill>
+            <a:srgbClr val="1496A6"/>
+          </a:solidFill>
+          <a:ln/>
+        </p:spPr>
+      </p:sp>
+      <p:sp>
+        <p:nvSpPr>
+          <p:cNvPr id="3" name="Text 1"/>
+          <p:cNvSpPr/>
+          <p:nvPr/>
+        </p:nvSpPr>
+        <p:spPr>
+          <a:xfrm>
+            <a:off x="804672" y="402336"/>
+            <a:ext cx="10515600" cy="274320"/>
+          </a:xfrm>
+          <a:prstGeom prst="rect">
+            <a:avLst/>
+          </a:prstGeom>
+          <a:noFill/>
+          <a:ln/>
+        </p:spPr>
+        <p:txBody>
+          <a:bodyPr wrap="square" lIns="0" tIns="0" rIns="0" bIns="0" rtlCol="0" anchor="ctr"/>
+          <a:lstStyle/>
+          <a:p>
+            <a:pPr indent="0" marL="0">
+              <a:buNone/>
+            </a:pPr>
+            <a:r>
+              <a:rPr lang="en-US" sz="1300" b="1" spc="200" kern="0" dirty="0">
+                <a:solidFill>
+                  <a:srgbClr val="13678A"/>
+                </a:solidFill>
+                <a:latin typeface="Trebuchet MS" pitchFamily="34" charset="0"/>
+                <a:ea typeface="Trebuchet MS" pitchFamily="34" charset="-122"/>
+                <a:cs typeface="Trebuchet MS" pitchFamily="34" charset="-120"/>
+              </a:rPr>
+              <a:t>DEPLOYMENT</a:t>
+            </a:r>
+            <a:endParaRPr lang="en-US" sz="1300" dirty="0"/>
+          </a:p>
+        </p:txBody>
+      </p:sp>
+      <p:sp>
+        <p:nvSpPr>
+          <p:cNvPr id="4" name="Text 2"/>
+          <p:cNvSpPr/>
+          <p:nvPr/>
+        </p:nvSpPr>
+        <p:spPr>
+          <a:xfrm>
+            <a:off x="804672" y="658368"/>
+            <a:ext cx="11155680" cy="566928"/>
+          </a:xfrm>
+          <a:prstGeom prst="rect">
+            <a:avLst/>
+          </a:prstGeom>
+          <a:noFill/>
+          <a:ln/>
+        </p:spPr>
+        <p:txBody>
+          <a:bodyPr wrap="square" lIns="0" tIns="0" rIns="0" bIns="0" rtlCol="0" anchor="ctr"/>
+          <a:lstStyle/>
+          <a:p>
+            <a:pPr indent="0" marL="0">
+              <a:buNone/>
+            </a:pPr>
+            <a:r>
+              <a:rPr lang="en-US" sz="2700" b="1" dirty="0">
+                <a:solidFill>
+                  <a:srgbClr val="0B2545"/>
+                </a:solidFill>
+                <a:latin typeface="Trebuchet MS" pitchFamily="34" charset="0"/>
+                <a:ea typeface="Trebuchet MS" pitchFamily="34" charset="-122"/>
+                <a:cs typeface="Trebuchet MS" pitchFamily="34" charset="-120"/>
+              </a:rPr>
+              <a:t>One core — install what your role needs</a:t>
+            </a:r>
+            <a:endParaRPr lang="en-US" sz="2700" dirty="0"/>
+          </a:p>
+        </p:txBody>
+      </p:sp>
+      <p:sp>
+        <p:nvSpPr>
+          <p:cNvPr id="5" name="Text 3"/>
+          <p:cNvSpPr/>
+          <p:nvPr/>
+        </p:nvSpPr>
+        <p:spPr>
+          <a:xfrm>
+            <a:off x="804672" y="1261872"/>
+            <a:ext cx="11155680" cy="365760"/>
+          </a:xfrm>
+          <a:prstGeom prst="rect">
+            <a:avLst/>
+          </a:prstGeom>
+          <a:noFill/>
+          <a:ln/>
+        </p:spPr>
+        <p:txBody>
+          <a:bodyPr wrap="square" lIns="0" tIns="0" rIns="0" bIns="0" rtlCol="0" anchor="ctr"/>
+          <a:lstStyle/>
+          <a:p>
+            <a:pPr indent="0" marL="0">
+              <a:buNone/>
+            </a:pPr>
+            <a:r>
+              <a:rPr lang="en-US" sz="1400" i="1" dirty="0">
+                <a:solidFill>
+                  <a:srgbClr val="33495C"/>
+                </a:solidFill>
+                <a:latin typeface="Calibri" pitchFamily="34" charset="0"/>
+                <a:ea typeface="Calibri" pitchFamily="34" charset="-122"/>
+                <a:cs typeface="Calibri" pitchFamily="34" charset="-120"/>
+              </a:rPr>
+              <a:t>Not two ITK-SNAPs: one codebase, the face(s) each user needs.</a:t>
+            </a:r>
+            <a:endParaRPr lang="en-US" sz="1400" dirty="0"/>
+          </a:p>
+        </p:txBody>
+      </p:sp>
+      <p:sp>
+        <p:nvSpPr>
+          <p:cNvPr id="6" name="Shape 4"/>
+          <p:cNvSpPr/>
+          <p:nvPr/>
+        </p:nvSpPr>
+        <p:spPr>
+          <a:xfrm>
+            <a:off x="548640" y="1783080"/>
+            <a:ext cx="11091672" cy="841248"/>
+          </a:xfrm>
+          <a:prstGeom prst="roundRect">
+            <a:avLst>
+              <a:gd name="adj" fmla="val 7609"/>
+            </a:avLst>
+          </a:prstGeom>
+          <a:solidFill>
+            <a:srgbClr val="FFFFFF"/>
+          </a:solidFill>
+          <a:ln w="12700">
+            <a:solidFill>
+              <a:srgbClr val="DCE5EF"/>
+            </a:solidFill>
+            <a:prstDash val="solid"/>
+          </a:ln>
+          <a:effectLst>
+            <a:outerShdw sx="100000" sy="100000" kx="0" ky="0" algn="bl" rotWithShape="0" blurRad="114300" dist="38100" dir="5400000">
+              <a:srgbClr val="0B2545">
+                <a:alpha val="16000"/>
+              </a:srgbClr>
+            </a:outerShdw>
+          </a:effectLst>
+        </p:spPr>
+      </p:sp>
+      <p:sp>
+        <p:nvSpPr>
+          <p:cNvPr id="7" name="Shape 5"/>
+          <p:cNvSpPr/>
+          <p:nvPr/>
+        </p:nvSpPr>
+        <p:spPr>
+          <a:xfrm>
+            <a:off x="804672" y="1929384"/>
+            <a:ext cx="548640" cy="548640"/>
+          </a:xfrm>
+          <a:prstGeom prst="ellipse">
+            <a:avLst/>
+          </a:prstGeom>
+          <a:solidFill>
+            <a:srgbClr val="1496A6"/>
+          </a:solidFill>
+          <a:ln/>
+        </p:spPr>
+      </p:sp>
+      <p:pic>
+        <p:nvPicPr>
+          <p:cNvPr id="8" name="Image 0" descr="preencoded.png">    </p:cNvPr>
+          <p:cNvPicPr>
+            <a:picLocks noChangeAspect="1"/>
+          </p:cNvPicPr>
+          <p:nvPr/>
+        </p:nvPicPr>
+        <p:blipFill>
+          <a:blip r:embed="rId1"/>
+          <a:stretch>
+            <a:fillRect/>
+          </a:stretch>
+        </p:blipFill>
+        <p:spPr>
+          <a:xfrm>
+            <a:off x="950976" y="2075688"/>
+            <a:ext cx="256032" cy="256032"/>
+          </a:xfrm>
+          <a:prstGeom prst="rect">
+            <a:avLst/>
+          </a:prstGeom>
+        </p:spPr>
+      </p:pic>
+      <p:sp>
+        <p:nvSpPr>
+          <p:cNvPr id="9" name="Text 6"/>
+          <p:cNvSpPr/>
+          <p:nvPr/>
+        </p:nvSpPr>
+        <p:spPr>
+          <a:xfrm>
+            <a:off x="1508760" y="1783080"/>
+            <a:ext cx="3657600" cy="841248"/>
+          </a:xfrm>
+          <a:prstGeom prst="rect">
+            <a:avLst/>
+          </a:prstGeom>
+          <a:noFill/>
+          <a:ln/>
+        </p:spPr>
+        <p:txBody>
+          <a:bodyPr wrap="square" lIns="0" tIns="0" rIns="0" bIns="0" rtlCol="0" anchor="ctr"/>
+          <a:lstStyle/>
+          <a:p>
+            <a:pPr indent="0" marL="0">
+              <a:buNone/>
+            </a:pPr>
+            <a:r>
+              <a:rPr lang="en-US" sz="1500" b="1" dirty="0">
+                <a:solidFill>
+                  <a:srgbClr val="0B2545"/>
+                </a:solidFill>
+                <a:latin typeface="Trebuchet MS" pitchFamily="34" charset="0"/>
+                <a:ea typeface="Trebuchet MS" pitchFamily="34" charset="-122"/>
+                <a:cs typeface="Trebuchet MS" pitchFamily="34" charset="-120"/>
+              </a:rPr>
+              <a:t>Automation / HPC / CI</a:t>
+            </a:r>
+            <a:endParaRPr lang="en-US" sz="1500" dirty="0"/>
+          </a:p>
+        </p:txBody>
+      </p:sp>
+      <p:pic>
+        <p:nvPicPr>
+          <p:cNvPr id="10" name="Image 1" descr="preencoded.png">    </p:cNvPr>
+          <p:cNvPicPr>
+            <a:picLocks noChangeAspect="1"/>
+          </p:cNvPicPr>
+          <p:nvPr/>
+        </p:nvPicPr>
+        <p:blipFill>
+          <a:blip r:embed="rId2"/>
+          <a:stretch>
+            <a:fillRect/>
+          </a:stretch>
+        </p:blipFill>
+        <p:spPr>
+          <a:xfrm>
+            <a:off x="5120640" y="2057400"/>
+            <a:ext cx="310896" cy="310896"/>
+          </a:xfrm>
+          <a:prstGeom prst="rect">
+            <a:avLst/>
+          </a:prstGeom>
+        </p:spPr>
+      </p:pic>
+      <p:sp>
+        <p:nvSpPr>
+          <p:cNvPr id="11" name="Text 7"/>
+          <p:cNvSpPr/>
+          <p:nvPr/>
+        </p:nvSpPr>
+        <p:spPr>
+          <a:xfrm>
+            <a:off x="5623560" y="1783080"/>
+            <a:ext cx="5788152" cy="841248"/>
+          </a:xfrm>
+          <a:prstGeom prst="rect">
+            <a:avLst/>
+          </a:prstGeom>
+          <a:noFill/>
+          <a:ln/>
+        </p:spPr>
+        <p:txBody>
+          <a:bodyPr wrap="square" lIns="0" tIns="0" rIns="0" bIns="0" rtlCol="0" anchor="ctr"/>
+          <a:lstStyle/>
+          <a:p>
+            <a:pPr indent="0" marL="0">
+              <a:buNone/>
+            </a:pPr>
+            <a:r>
+              <a:rPr lang="en-US" sz="1400" dirty="0">
+                <a:solidFill>
+                  <a:srgbClr val="33495C"/>
+                </a:solidFill>
+                <a:latin typeface="Calibri" pitchFamily="34" charset="0"/>
+                <a:ea typeface="Calibri" pitchFamily="34" charset="-122"/>
+                <a:cs typeface="Calibri" pitchFamily="34" charset="-120"/>
+              </a:rPr>
+              <a:t>pip headless library (no GUI)</a:t>
+            </a:r>
+            <a:endParaRPr lang="en-US" sz="1400" dirty="0"/>
+          </a:p>
+        </p:txBody>
+      </p:sp>
+      <p:sp>
+        <p:nvSpPr>
+          <p:cNvPr id="12" name="Shape 8"/>
+          <p:cNvSpPr/>
+          <p:nvPr/>
+        </p:nvSpPr>
+        <p:spPr>
+          <a:xfrm>
+            <a:off x="548640" y="2743200"/>
+            <a:ext cx="11091672" cy="841248"/>
+          </a:xfrm>
+          <a:prstGeom prst="roundRect">
+            <a:avLst>
+              <a:gd name="adj" fmla="val 7609"/>
+            </a:avLst>
+          </a:prstGeom>
+          <a:solidFill>
+            <a:srgbClr val="FFFFFF"/>
+          </a:solidFill>
+          <a:ln w="12700">
+            <a:solidFill>
+              <a:srgbClr val="DCE5EF"/>
+            </a:solidFill>
+            <a:prstDash val="solid"/>
+          </a:ln>
+          <a:effectLst>
+            <a:outerShdw sx="100000" sy="100000" kx="0" ky="0" algn="bl" rotWithShape="0" blurRad="114300" dist="38100" dir="5400000">
+              <a:srgbClr val="0B2545">
+                <a:alpha val="16000"/>
+              </a:srgbClr>
+            </a:outerShdw>
+          </a:effectLst>
+        </p:spPr>
+      </p:sp>
+      <p:sp>
+        <p:nvSpPr>
+          <p:cNvPr id="13" name="Shape 9"/>
+          <p:cNvSpPr/>
+          <p:nvPr/>
+        </p:nvSpPr>
+        <p:spPr>
+          <a:xfrm>
+            <a:off x="804672" y="2889504"/>
+            <a:ext cx="548640" cy="548640"/>
+          </a:xfrm>
+          <a:prstGeom prst="ellipse">
+            <a:avLst/>
+          </a:prstGeom>
+          <a:solidFill>
+            <a:srgbClr val="E8924A"/>
+          </a:solidFill>
+          <a:ln/>
+        </p:spPr>
+      </p:sp>
+      <p:pic>
+        <p:nvPicPr>
+          <p:cNvPr id="14" name="Image 2" descr="preencoded.png">    </p:cNvPr>
+          <p:cNvPicPr>
+            <a:picLocks noChangeAspect="1"/>
+          </p:cNvPicPr>
+          <p:nvPr/>
+        </p:nvPicPr>
+        <p:blipFill>
+          <a:blip r:embed="rId3"/>
+          <a:stretch>
+            <a:fillRect/>
+          </a:stretch>
+        </p:blipFill>
+        <p:spPr>
+          <a:xfrm>
+            <a:off x="950976" y="3035808"/>
+            <a:ext cx="256032" cy="256032"/>
+          </a:xfrm>
+          <a:prstGeom prst="rect">
+            <a:avLst/>
+          </a:prstGeom>
+        </p:spPr>
+      </p:pic>
+      <p:sp>
+        <p:nvSpPr>
+          <p:cNvPr id="15" name="Text 10"/>
+          <p:cNvSpPr/>
+          <p:nvPr/>
+        </p:nvSpPr>
+        <p:spPr>
+          <a:xfrm>
+            <a:off x="1508760" y="2743200"/>
+            <a:ext cx="3657600" cy="841248"/>
+          </a:xfrm>
+          <a:prstGeom prst="rect">
+            <a:avLst/>
+          </a:prstGeom>
+          <a:noFill/>
+          <a:ln/>
+        </p:spPr>
+        <p:txBody>
+          <a:bodyPr wrap="square" lIns="0" tIns="0" rIns="0" bIns="0" rtlCol="0" anchor="ctr"/>
+          <a:lstStyle/>
+          <a:p>
+            <a:pPr indent="0" marL="0">
+              <a:buNone/>
+            </a:pPr>
+            <a:r>
+              <a:rPr lang="en-US" sz="1500" b="1" dirty="0">
+                <a:solidFill>
+                  <a:srgbClr val="0B2545"/>
+                </a:solidFill>
+                <a:latin typeface="Trebuchet MS" pitchFamily="34" charset="0"/>
+                <a:ea typeface="Trebuchet MS" pitchFamily="34" charset="-122"/>
+                <a:cs typeface="Trebuchet MS" pitchFamily="34" charset="-120"/>
+              </a:rPr>
+              <a:t>Interactive expert</a:t>
+            </a:r>
+            <a:endParaRPr lang="en-US" sz="1500" dirty="0"/>
+          </a:p>
+        </p:txBody>
+      </p:sp>
+      <p:pic>
+        <p:nvPicPr>
+          <p:cNvPr id="16" name="Image 3" descr="preencoded.png">    </p:cNvPr>
+          <p:cNvPicPr>
+            <a:picLocks noChangeAspect="1"/>
+          </p:cNvPicPr>
+          <p:nvPr/>
+        </p:nvPicPr>
+        <p:blipFill>
+          <a:blip r:embed="rId4"/>
+          <a:stretch>
+            <a:fillRect/>
+          </a:stretch>
+        </p:blipFill>
+        <p:spPr>
+          <a:xfrm>
+            <a:off x="5120640" y="3017520"/>
+            <a:ext cx="310896" cy="310896"/>
+          </a:xfrm>
+          <a:prstGeom prst="rect">
+            <a:avLst/>
+          </a:prstGeom>
+        </p:spPr>
+      </p:pic>
+      <p:sp>
+        <p:nvSpPr>
+          <p:cNvPr id="17" name="Text 11"/>
+          <p:cNvSpPr/>
+          <p:nvPr/>
+        </p:nvSpPr>
+        <p:spPr>
+          <a:xfrm>
+            <a:off x="5623560" y="2743200"/>
+            <a:ext cx="5788152" cy="841248"/>
+          </a:xfrm>
+          <a:prstGeom prst="rect">
+            <a:avLst/>
+          </a:prstGeom>
+          <a:noFill/>
+          <a:ln/>
+        </p:spPr>
+        <p:txBody>
+          <a:bodyPr wrap="square" lIns="0" tIns="0" rIns="0" bIns="0" rtlCol="0" anchor="ctr"/>
+          <a:lstStyle/>
+          <a:p>
+            <a:pPr indent="0" marL="0">
+              <a:buNone/>
+            </a:pPr>
+            <a:r>
+              <a:rPr lang="en-US" sz="1400" dirty="0">
+                <a:solidFill>
+                  <a:srgbClr val="33495C"/>
+                </a:solidFill>
+                <a:latin typeface="Calibri" pitchFamily="34" charset="0"/>
+                <a:ea typeface="Calibri" pitchFamily="34" charset="-122"/>
+                <a:cs typeface="Calibri" pitchFamily="34" charset="-120"/>
+              </a:rPr>
+              <a:t>Desktop app (also agent-ready via MCP)</a:t>
+            </a:r>
+            <a:endParaRPr lang="en-US" sz="1400" dirty="0"/>
+          </a:p>
+        </p:txBody>
+      </p:sp>
+      <p:sp>
+        <p:nvSpPr>
+          <p:cNvPr id="18" name="Shape 12"/>
+          <p:cNvSpPr/>
+          <p:nvPr/>
+        </p:nvSpPr>
+        <p:spPr>
+          <a:xfrm>
+            <a:off x="548640" y="3703320"/>
+            <a:ext cx="11091672" cy="841248"/>
+          </a:xfrm>
+          <a:prstGeom prst="roundRect">
+            <a:avLst>
+              <a:gd name="adj" fmla="val 7609"/>
+            </a:avLst>
+          </a:prstGeom>
+          <a:solidFill>
+            <a:srgbClr val="FFFFFF"/>
+          </a:solidFill>
+          <a:ln w="12700">
+            <a:solidFill>
+              <a:srgbClr val="DCE5EF"/>
+            </a:solidFill>
+            <a:prstDash val="solid"/>
+          </a:ln>
+          <a:effectLst>
+            <a:outerShdw sx="100000" sy="100000" kx="0" ky="0" algn="bl" rotWithShape="0" blurRad="114300" dist="38100" dir="5400000">
+              <a:srgbClr val="0B2545">
+                <a:alpha val="16000"/>
+              </a:srgbClr>
+            </a:outerShdw>
+          </a:effectLst>
+        </p:spPr>
+      </p:sp>
+      <p:sp>
+        <p:nvSpPr>
+          <p:cNvPr id="19" name="Shape 13"/>
+          <p:cNvSpPr/>
+          <p:nvPr/>
+        </p:nvSpPr>
+        <p:spPr>
+          <a:xfrm>
+            <a:off x="804672" y="3849624"/>
+            <a:ext cx="548640" cy="548640"/>
+          </a:xfrm>
+          <a:prstGeom prst="ellipse">
+            <a:avLst/>
+          </a:prstGeom>
+          <a:solidFill>
+            <a:srgbClr val="2BB3A3"/>
+          </a:solidFill>
+          <a:ln/>
+        </p:spPr>
+      </p:sp>
+      <p:pic>
+        <p:nvPicPr>
+          <p:cNvPr id="20" name="Image 4" descr="preencoded.png">    </p:cNvPr>
+          <p:cNvPicPr>
+            <a:picLocks noChangeAspect="1"/>
+          </p:cNvPicPr>
+          <p:nvPr/>
+        </p:nvPicPr>
+        <p:blipFill>
+          <a:blip r:embed="rId5"/>
+          <a:stretch>
+            <a:fillRect/>
+          </a:stretch>
+        </p:blipFill>
+        <p:spPr>
+          <a:xfrm>
+            <a:off x="950976" y="3995928"/>
+            <a:ext cx="256032" cy="256032"/>
+          </a:xfrm>
+          <a:prstGeom prst="rect">
+            <a:avLst/>
+          </a:prstGeom>
+        </p:spPr>
+      </p:pic>
+      <p:sp>
+        <p:nvSpPr>
+          <p:cNvPr id="21" name="Text 14"/>
+          <p:cNvSpPr/>
+          <p:nvPr/>
+        </p:nvSpPr>
+        <p:spPr>
+          <a:xfrm>
+            <a:off x="1508760" y="3703320"/>
+            <a:ext cx="3657600" cy="841248"/>
+          </a:xfrm>
+          <a:prstGeom prst="rect">
+            <a:avLst/>
+          </a:prstGeom>
+          <a:noFill/>
+          <a:ln/>
+        </p:spPr>
+        <p:txBody>
+          <a:bodyPr wrap="square" lIns="0" tIns="0" rIns="0" bIns="0" rtlCol="0" anchor="ctr"/>
+          <a:lstStyle/>
+          <a:p>
+            <a:pPr indent="0" marL="0">
+              <a:buNone/>
+            </a:pPr>
+            <a:r>
+              <a:rPr lang="en-US" sz="1500" b="1" dirty="0">
+                <a:solidFill>
+                  <a:srgbClr val="0B2545"/>
+                </a:solidFill>
+                <a:latin typeface="Trebuchet MS" pitchFamily="34" charset="0"/>
+                <a:ea typeface="Trebuchet MS" pitchFamily="34" charset="-122"/>
+                <a:cs typeface="Trebuchet MS" pitchFamily="34" charset="-120"/>
+              </a:rPr>
+              <a:t>Notebook + occasional human</a:t>
+            </a:r>
+            <a:endParaRPr lang="en-US" sz="1500" dirty="0"/>
+          </a:p>
+        </p:txBody>
+      </p:sp>
+      <p:pic>
+        <p:nvPicPr>
+          <p:cNvPr id="22" name="Image 5" descr="preencoded.png">    </p:cNvPr>
+          <p:cNvPicPr>
+            <a:picLocks noChangeAspect="1"/>
+          </p:cNvPicPr>
+          <p:nvPr/>
+        </p:nvPicPr>
+        <p:blipFill>
+          <a:blip r:embed="rId6"/>
+          <a:stretch>
+            <a:fillRect/>
+          </a:stretch>
+        </p:blipFill>
+        <p:spPr>
+          <a:xfrm>
+            <a:off x="5120640" y="3977640"/>
+            <a:ext cx="310896" cy="310896"/>
+          </a:xfrm>
+          <a:prstGeom prst="rect">
+            <a:avLst/>
+          </a:prstGeom>
+        </p:spPr>
+      </p:pic>
+      <p:sp>
+        <p:nvSpPr>
+          <p:cNvPr id="23" name="Text 15"/>
+          <p:cNvSpPr/>
+          <p:nvPr/>
+        </p:nvSpPr>
+        <p:spPr>
+          <a:xfrm>
+            <a:off x="5623560" y="3703320"/>
+            <a:ext cx="5788152" cy="841248"/>
+          </a:xfrm>
+          <a:prstGeom prst="rect">
+            <a:avLst/>
+          </a:prstGeom>
+          <a:noFill/>
+          <a:ln/>
+        </p:spPr>
+        <p:txBody>
+          <a:bodyPr wrap="square" lIns="0" tIns="0" rIns="0" bIns="0" rtlCol="0" anchor="ctr"/>
+          <a:lstStyle/>
+          <a:p>
+            <a:pPr indent="0" marL="0">
+              <a:buNone/>
+            </a:pPr>
+            <a:r>
+              <a:rPr lang="en-US" sz="1400" dirty="0">
+                <a:solidFill>
+                  <a:srgbClr val="33495C"/>
+                </a:solidFill>
+                <a:latin typeface="Calibri" pitchFamily="34" charset="0"/>
+                <a:ea typeface="Calibri" pitchFamily="34" charset="-122"/>
+                <a:cs typeface="Calibri" pitchFamily="34" charset="-120"/>
+              </a:rPr>
+              <a:t>pip library + web viewer (browser — no extra install)</a:t>
+            </a:r>
+            <a:endParaRPr lang="en-US" sz="1400" dirty="0"/>
+          </a:p>
+        </p:txBody>
+      </p:sp>
+      <p:sp>
+        <p:nvSpPr>
+          <p:cNvPr id="24" name="Shape 16"/>
+          <p:cNvSpPr/>
+          <p:nvPr/>
+        </p:nvSpPr>
+        <p:spPr>
+          <a:xfrm>
+            <a:off x="548640" y="4754880"/>
+            <a:ext cx="11091672" cy="1005840"/>
+          </a:xfrm>
+          <a:prstGeom prst="roundRect">
+            <a:avLst>
+              <a:gd name="adj" fmla="val 6364"/>
+            </a:avLst>
+          </a:prstGeom>
+          <a:solidFill>
+            <a:srgbClr val="0B2545"/>
+          </a:solidFill>
+          <a:ln/>
+          <a:effectLst>
+            <a:outerShdw sx="100000" sy="100000" kx="0" ky="0" algn="bl" rotWithShape="0" blurRad="114300" dist="38100" dir="5400000">
+              <a:srgbClr val="0B2545">
+                <a:alpha val="16000"/>
+              </a:srgbClr>
+            </a:outerShdw>
+          </a:effectLst>
+        </p:spPr>
+      </p:sp>
+      <p:sp>
+        <p:nvSpPr>
+          <p:cNvPr id="25" name="Text 17"/>
+          <p:cNvSpPr/>
+          <p:nvPr/>
+        </p:nvSpPr>
+        <p:spPr>
+          <a:xfrm>
+            <a:off x="841248" y="4846320"/>
+            <a:ext cx="10543032" cy="274320"/>
+          </a:xfrm>
+          <a:prstGeom prst="rect">
+            <a:avLst/>
+          </a:prstGeom>
+          <a:noFill/>
+          <a:ln/>
+        </p:spPr>
+        <p:txBody>
+          <a:bodyPr wrap="square" lIns="0" tIns="0" rIns="0" bIns="0" rtlCol="0" anchor="ctr"/>
+          <a:lstStyle/>
+          <a:p>
+            <a:pPr indent="0" marL="0">
+              <a:buNone/>
+            </a:pPr>
+            <a:r>
+              <a:rPr lang="en-US" sz="1200" b="1" spc="100" kern="0" dirty="0">
+                <a:solidFill>
+                  <a:srgbClr val="2BB3A3"/>
+                </a:solidFill>
+                <a:latin typeface="Trebuchet MS" pitchFamily="34" charset="0"/>
+                <a:ea typeface="Trebuchet MS" pitchFamily="34" charset="-122"/>
+                <a:cs typeface="Trebuchet MS" pitchFamily="34" charset="-120"/>
+              </a:rPr>
+              <a:t>Principles</a:t>
+            </a:r>
+            <a:endParaRPr lang="en-US" sz="1200" dirty="0"/>
+          </a:p>
+        </p:txBody>
+      </p:sp>
+      <p:sp>
+        <p:nvSpPr>
+          <p:cNvPr id="26" name="Text 18"/>
+          <p:cNvSpPr/>
+          <p:nvPr/>
+        </p:nvSpPr>
+        <p:spPr>
+          <a:xfrm>
+            <a:off x="841248" y="5120640"/>
+            <a:ext cx="10506456" cy="594360"/>
+          </a:xfrm>
+          <a:prstGeom prst="rect">
+            <a:avLst/>
+          </a:prstGeom>
+          <a:noFill/>
+          <a:ln/>
+        </p:spPr>
+        <p:txBody>
+          <a:bodyPr wrap="square" lIns="0" tIns="0" rIns="0" bIns="0" rtlCol="0" anchor="t"/>
+          <a:lstStyle/>
+          <a:p>
+            <a:pPr indent="0" marL="0">
+              <a:buNone/>
+            </a:pPr>
+            <a:r>
+              <a:rPr lang="en-US" sz="1250" dirty="0">
+                <a:solidFill>
+                  <a:srgbClr val="E6EEF7"/>
+                </a:solidFill>
+                <a:latin typeface="Calibri" pitchFamily="34" charset="0"/>
+                <a:ea typeface="Calibri" pitchFamily="34" charset="-122"/>
+                <a:cs typeface="Calibri" pitchFamily="34" charset="-120"/>
+              </a:rPr>
+              <a:t>Headless core makes human-in-the-loop callable &amp; scalable — not optional.</a:t>
+            </a:r>
+            <a:endParaRPr lang="en-US" sz="1250" dirty="0"/>
+          </a:p>
+          <a:p>
+            <a:pPr indent="0" marL="0">
+              <a:buNone/>
+            </a:pPr>
+            <a:r>
+              <a:rPr lang="en-US" sz="1250" dirty="0">
+                <a:solidFill>
+                  <a:srgbClr val="E6EEF7"/>
+                </a:solidFill>
+                <a:latin typeface="Calibri" pitchFamily="34" charset="0"/>
+                <a:ea typeface="Calibri" pitchFamily="34" charset="-122"/>
+                <a:cs typeface="Calibri" pitchFamily="34" charset="-120"/>
+              </a:rPr>
+              <a:t>Web viewer = zero-install human surface  ·  MCP can be C++ or Python (not Python-locked)  ·  pip = the engine, not the GUI app.</a:t>
+            </a:r>
+            <a:endParaRPr lang="en-US" sz="1250" dirty="0"/>
+          </a:p>
+        </p:txBody>
+      </p:sp>
+      <p:sp>
+        <p:nvSpPr>
+          <p:cNvPr id="27" name="Text 19"/>
+          <p:cNvSpPr/>
+          <p:nvPr/>
+        </p:nvSpPr>
+        <p:spPr>
+          <a:xfrm>
+            <a:off x="548640" y="6446520"/>
+            <a:ext cx="8229600" cy="274320"/>
+          </a:xfrm>
+          <a:prstGeom prst="rect">
+            <a:avLst/>
+          </a:prstGeom>
+          <a:noFill/>
+          <a:ln/>
+        </p:spPr>
+        <p:txBody>
+          <a:bodyPr wrap="square" lIns="0" tIns="0" rIns="0" bIns="0" rtlCol="0" anchor="ctr"/>
+          <a:lstStyle/>
+          <a:p>
+            <a:pPr indent="0" marL="0">
+              <a:buNone/>
+            </a:pPr>
+            <a:r>
+              <a:rPr lang="en-US" sz="900" dirty="0">
+                <a:solidFill>
+                  <a:srgbClr val="6B7B8C"/>
+                </a:solidFill>
+                <a:latin typeface="Calibri" pitchFamily="34" charset="0"/>
+                <a:ea typeface="Calibri" pitchFamily="34" charset="-122"/>
+                <a:cs typeface="Calibri" pitchFamily="34" charset="-120"/>
+              </a:rPr>
+              <a:t>OS4LS 2026  ·  ITK-SNAP AI-Native, Human-in-the-Loop Segmentation</a:t>
+            </a:r>
+            <a:endParaRPr lang="en-US" sz="900" dirty="0"/>
+          </a:p>
+        </p:txBody>
+      </p:sp>
+      <p:sp>
+        <p:nvSpPr>
+          <p:cNvPr id="28" name="Text 20"/>
+          <p:cNvSpPr/>
+          <p:nvPr/>
+        </p:nvSpPr>
+        <p:spPr>
+          <a:xfrm>
+            <a:off x="11274552" y="6446520"/>
+            <a:ext cx="365760" cy="274320"/>
+          </a:xfrm>
+          <a:prstGeom prst="rect">
+            <a:avLst/>
+          </a:prstGeom>
+          <a:noFill/>
+          <a:ln/>
+        </p:spPr>
+        <p:txBody>
+          <a:bodyPr wrap="square" lIns="0" tIns="0" rIns="0" bIns="0" rtlCol="0" anchor="ctr"/>
+          <a:lstStyle/>
+          <a:p>
+            <a:pPr algn="r" indent="0" marL="0">
+              <a:buNone/>
+            </a:pPr>
+            <a:r>
+              <a:rPr lang="en-US" sz="900" dirty="0">
+                <a:solidFill>
+                  <a:srgbClr val="6B7B8C"/>
+                </a:solidFill>
+                <a:latin typeface="Calibri" pitchFamily="34" charset="0"/>
+                <a:ea typeface="Calibri" pitchFamily="34" charset="-122"/>
+                <a:cs typeface="Calibri" pitchFamily="34" charset="-120"/>
+              </a:rPr>
+              <a:t>14</a:t>
+            </a:r>
+            <a:endParaRPr lang="en-US" sz="900" dirty="0"/>
+          </a:p>
+        </p:txBody>
+      </p:sp>
+    </p:spTree>
+  </p:cSld>
+  <p:clrMapOvr>
+    <a:masterClrMapping/>
+  </p:clrMapOvr>
+</p:sld>
+</file>
+
+<file path=ppt/slides/slide15.xml><?xml version="1.0" encoding="utf-8"?>
+<p:sld xmlns:a="http://schemas.openxmlformats.org/drawingml/2006/main" xmlns:r="http://schemas.openxmlformats.org/officeDocument/2006/relationships" xmlns:p="http://schemas.openxmlformats.org/presentationml/2006/main">
+  <p:cSld name="Slide 15">
+    <p:bg>
+      <p:bgPr>
+        <a:solidFill>
+          <a:srgbClr val="F4F7FB"/>
+        </a:solidFill>
+      </p:bgPr>
+    </p:bg>
+    <p:spTree>
+      <p:nvGrpSpPr>
+        <p:cNvPr id="1" name=""/>
+        <p:cNvGrpSpPr/>
+        <p:nvPr/>
+      </p:nvGrpSpPr>
+      <p:grpSpPr>
+        <a:xfrm>
+          <a:off x="0" y="0"/>
+          <a:ext cx="0" cy="0"/>
+          <a:chOff x="0" y="0"/>
+          <a:chExt cx="0" cy="0"/>
+        </a:xfrm>
+      </p:grpSpPr>
+      <p:sp>
+        <p:nvSpPr>
+          <p:cNvPr id="2" name="Shape 0"/>
+          <p:cNvSpPr/>
+          <p:nvPr/>
+        </p:nvSpPr>
+        <p:spPr>
+          <a:xfrm>
+            <a:off x="548640" y="420624"/>
+            <a:ext cx="146304" cy="457200"/>
+          </a:xfrm>
+          <a:prstGeom prst="rect">
+            <a:avLst/>
+          </a:prstGeom>
+          <a:solidFill>
+            <a:srgbClr val="1496A6"/>
+          </a:solidFill>
+          <a:ln/>
+        </p:spPr>
+      </p:sp>
+      <p:sp>
+        <p:nvSpPr>
+          <p:cNvPr id="3" name="Text 1"/>
+          <p:cNvSpPr/>
+          <p:nvPr/>
+        </p:nvSpPr>
+        <p:spPr>
+          <a:xfrm>
+            <a:off x="804672" y="402336"/>
+            <a:ext cx="10515600" cy="274320"/>
+          </a:xfrm>
+          <a:prstGeom prst="rect">
+            <a:avLst/>
+          </a:prstGeom>
+          <a:noFill/>
+          <a:ln/>
+        </p:spPr>
+        <p:txBody>
+          <a:bodyPr wrap="square" lIns="0" tIns="0" rIns="0" bIns="0" rtlCol="0" anchor="ctr"/>
+          <a:lstStyle/>
+          <a:p>
+            <a:pPr indent="0" marL="0">
+              <a:buNone/>
+            </a:pPr>
+            <a:r>
+              <a:rPr lang="en-US" sz="1300" b="1" spc="200" kern="0" dirty="0">
+                <a:solidFill>
+                  <a:srgbClr val="13678A"/>
+                </a:solidFill>
+                <a:latin typeface="Trebuchet MS" pitchFamily="34" charset="0"/>
+                <a:ea typeface="Trebuchet MS" pitchFamily="34" charset="-122"/>
+                <a:cs typeface="Trebuchet MS" pitchFamily="34" charset="-120"/>
+              </a:rPr>
               <a:t>STRATEGY</a:t>
             </a:r>
             <a:endParaRPr lang="en-US" sz="1300" dirty="0"/>
@@ -5029,7 +8377,7 @@
                 <a:ea typeface="Calibri" pitchFamily="34" charset="-122"/>
                 <a:cs typeface="Calibri" pitchFamily="34" charset="-120"/>
               </a:rPr>
-              <a:t>12</a:t>
+              <a:t>15</a:t>
             </a:r>
             <a:endParaRPr lang="en-US" sz="900" dirty="0"/>
           </a:p>
@@ -5043,9 +8391,9 @@
 </p:sld>
 </file>
 
-<file path=ppt/slides/slide13.xml><?xml version="1.0" encoding="utf-8"?>
+<file path=ppt/slides/slide16.xml><?xml version="1.0" encoding="utf-8"?>
 <p:sld xmlns:a="http://schemas.openxmlformats.org/drawingml/2006/main" xmlns:r="http://schemas.openxmlformats.org/officeDocument/2006/relationships" xmlns:p="http://schemas.openxmlformats.org/presentationml/2006/main">
-  <p:cSld name="Slide 13">
+  <p:cSld name="Slide 16">
     <p:bg>
       <p:bgPr>
         <a:solidFill>
@@ -6131,7 +9479,7 @@
                 <a:ea typeface="Calibri" pitchFamily="34" charset="-122"/>
                 <a:cs typeface="Calibri" pitchFamily="34" charset="-120"/>
               </a:rPr>
-              <a:t>13</a:t>
+              <a:t>16</a:t>
             </a:r>
             <a:endParaRPr lang="en-US" sz="900" dirty="0"/>
           </a:p>

</xml_diff>